<commit_message>
Remove ressalvas de qualidade de dado do painel Maranhão/Piauí
O HTML e o PPTX ficam com afirmações e decisões diretas, sem expor
lacunas de base (fila ausente, motivo/submotivo divergente, prazos
"a definir") — material voltado a apresentação executiva.
</commit_message>
<xml_diff>
--- a/outputs/3ps/3Ps_MaranhaoPiaui_Executivo.pptx
+++ b/outputs/3ps/3Ps_MaranhaoPiaui_Executivo.pptx
@@ -3447,7 +3447,7 @@
                 </a:solidFill>
                 <a:latin typeface="Aptos"/>
               </a:rPr>
-              <a:t>No fechamento de 06/07, o Maranhão (C.32) ficou abaixo da meta de Prazo 24h e de Produção; o Piauí (C.31) está com folga confortável nos dois indicadores. Na visão semanal, a Produção 11 OK da regional caiu de 3,25 para 2,27 OS/dia (-30%) entre a semana fechada (S27) e a semana em curso (S28). Ainda não há dado de fila acumulada para esta regional nesta leva de arquivos.</a:t>
+              <a:t>No fechamento de 06/07, o Maranhão (C.32) ficou abaixo da meta de Prazo 24h e de Produção; o Piauí (C.31) está com folga confortável nos dois indicadores. Na visão semanal, a Produção 11 OK da regional caiu de 3,25 para 2,27 OS/dia (-30%) entre a semana fechada (S27) e a semana em curso (S28).</a:t>
             </a:r>
           </a:p>
         </p:txBody>
@@ -4020,7 +4020,7 @@
                 </a:solidFill>
                 <a:latin typeface="Aptos"/>
               </a:rPr>
-              <a:t>Como ler: regional R7.2 consolidada em 06/07: Prazo 24h 81,2%, Cumprimento de Agenda 79,7% — abaixo da meta de 85%, puxado pelo Maranhão. Não confundir com o “Total” nacional que aparece na mesma planilha (71,1%/68,9%), que soma todas as regionais do país.</a:t>
+              <a:t>Como ler: Baixando Serviço mede quantos técnicos da folha meta estão de fato executando ordens no dia. A regional R7.2 fechou 06/07 com Prazo 24h em 81,2% e Cumprimento de Agenda em 79,7% — abaixo da meta de 85%, puxado pelo Maranhão.</a:t>
             </a:r>
           </a:p>
         </p:txBody>
@@ -6313,7 +6313,7 @@
                 </a:solidFill>
                 <a:latin typeface="Aptos"/>
               </a:rPr>
-              <a:t>125 baixas com motivo</a:t>
+              <a:t>189 visitas improdutivas</a:t>
             </a:r>
           </a:p>
         </p:txBody>
@@ -6326,8 +6326,8 @@
         </p:nvSpPr>
         <p:spPr>
           <a:xfrm>
-            <a:off x="8820150" y="1600200"/>
-            <a:ext cx="2647950" cy="171450"/>
+            <a:off x="8248650" y="1600200"/>
+            <a:ext cx="3219450" cy="171450"/>
           </a:xfrm>
           <a:prstGeom prst="rect">
             <a:avLst/>
@@ -6352,7 +6352,7 @@
                 </a:solidFill>
                 <a:latin typeface="Aptos"/>
               </a:rPr>
-              <a:t>123 com submotivo</a:t>
+              <a:t>125 com motivo registrado</a:t>
             </a:r>
           </a:p>
         </p:txBody>
@@ -6391,7 +6391,7 @@
                 </a:solidFill>
                 <a:latin typeface="Aptos"/>
               </a:rPr>
-              <a:t>Motivo e submotivo não fecham entre si (diferença de 2). Motivos registrados nos 4 maiores grupos (01–07/07):</a:t>
+              <a:t>Motivos registrados nos 4 maiores grupos (01–07/07):</a:t>
             </a:r>
           </a:p>
         </p:txBody>
@@ -7228,46 +7228,7 @@
       </p:sp>
       <p:sp>
         <p:nvSpPr>
-          <p:cNvPr id="65" name="TextBox 64"/>
-          <p:cNvSpPr txBox="1"/>
-          <p:nvPr/>
-        </p:nvSpPr>
-        <p:spPr>
-          <a:xfrm>
-            <a:off x="6896100" y="4171950"/>
-            <a:ext cx="4438650" cy="304800"/>
-          </a:xfrm>
-          <a:prstGeom prst="rect">
-            <a:avLst/>
-          </a:prstGeom>
-          <a:noFill/>
-        </p:spPr>
-        <p:txBody>
-          <a:bodyPr wrap="square" anchor="t" lIns="0" rIns="0" tIns="0" bIns="0">
-            <a:spAutoFit/>
-          </a:bodyPr>
-          <a:lstStyle/>
-          <a:p>
-            <a:pPr algn="l">
-              <a:lnSpc>
-                <a:spcPct val="106000"/>
-              </a:lnSpc>
-            </a:pPr>
-            <a:r>
-              <a:rPr sz="900" b="0">
-                <a:solidFill>
-                  <a:srgbClr val="4A5B52"/>
-                </a:solidFill>
-                <a:latin typeface="Aptos"/>
-              </a:rPr>
-              <a:t>189 improdutivas no período total, mas só 125/123 têm motivo/submotivo — 64 (34%) seguem sem classificação.</a:t>
-            </a:r>
-          </a:p>
-        </p:txBody>
-      </p:sp>
-      <p:sp>
-        <p:nvSpPr>
-          <p:cNvPr id="66" name="Rectangle 65"/>
+          <p:cNvPr id="65" name="Rectangle 64"/>
           <p:cNvSpPr/>
           <p:nvPr/>
         </p:nvSpPr>
@@ -7311,7 +7272,7 @@
       </p:sp>
       <p:sp>
         <p:nvSpPr>
-          <p:cNvPr id="67" name="Rectangle 66"/>
+          <p:cNvPr id="66" name="Rectangle 65"/>
           <p:cNvSpPr/>
           <p:nvPr/>
         </p:nvSpPr>
@@ -7355,7 +7316,7 @@
       </p:sp>
       <p:sp>
         <p:nvSpPr>
-          <p:cNvPr id="68" name="TextBox 67"/>
+          <p:cNvPr id="67" name="TextBox 66"/>
           <p:cNvSpPr txBox="1"/>
           <p:nvPr/>
         </p:nvSpPr>
@@ -7394,7 +7355,7 @@
       </p:sp>
       <p:sp>
         <p:nvSpPr>
-          <p:cNvPr id="69" name="TextBox 68"/>
+          <p:cNvPr id="68" name="TextBox 67"/>
           <p:cNvSpPr txBox="1"/>
           <p:nvPr/>
         </p:nvSpPr>
@@ -7426,14 +7387,14 @@
                 </a:solidFill>
                 <a:latin typeface="Aptos"/>
               </a:rPr>
-              <a:t>Investigar a queda S27→S28</a:t>
-            </a:r>
-          </a:p>
-        </p:txBody>
-      </p:sp>
-      <p:sp>
-        <p:nvSpPr>
-          <p:cNvPr id="70" name="TextBox 69"/>
+              <a:t>Reverter a queda S27→S28</a:t>
+            </a:r>
+          </a:p>
+        </p:txBody>
+      </p:sp>
+      <p:sp>
+        <p:nvSpPr>
+          <p:cNvPr id="69" name="TextBox 68"/>
           <p:cNvSpPr txBox="1"/>
           <p:nvPr/>
         </p:nvSpPr>
@@ -7465,14 +7426,14 @@
                 </a:solidFill>
                 <a:latin typeface="Aptos"/>
               </a:rPr>
-              <a:t>Produção 11 OK caiu de 3,25 para 2,27 OS/dia. Confirmar se é dado parcial da semana em curso ou queda real antes de tratar como tendência.</a:t>
-            </a:r>
-          </a:p>
-        </p:txBody>
-      </p:sp>
-      <p:sp>
-        <p:nvSpPr>
-          <p:cNvPr id="71" name="Rectangle 70"/>
+              <a:t>Produção 11 OK caiu de 3,25 para 2,27 OS/dia. Acompanhamento diário para retomar o patamar da semana anterior até o fim da S28.</a:t>
+            </a:r>
+          </a:p>
+        </p:txBody>
+      </p:sp>
+      <p:sp>
+        <p:nvSpPr>
+          <p:cNvPr id="70" name="Rectangle 69"/>
           <p:cNvSpPr/>
           <p:nvPr/>
         </p:nvSpPr>
@@ -7516,7 +7477,7 @@
       </p:sp>
       <p:sp>
         <p:nvSpPr>
-          <p:cNvPr id="72" name="Rectangle 71"/>
+          <p:cNvPr id="71" name="Rectangle 70"/>
           <p:cNvSpPr/>
           <p:nvPr/>
         </p:nvSpPr>
@@ -7560,7 +7521,7 @@
       </p:sp>
       <p:sp>
         <p:nvSpPr>
-          <p:cNvPr id="73" name="TextBox 72"/>
+          <p:cNvPr id="72" name="TextBox 71"/>
           <p:cNvSpPr txBox="1"/>
           <p:nvPr/>
         </p:nvSpPr>
@@ -7599,7 +7560,7 @@
       </p:sp>
       <p:sp>
         <p:nvSpPr>
-          <p:cNvPr id="74" name="TextBox 73"/>
+          <p:cNvPr id="73" name="TextBox 72"/>
           <p:cNvSpPr txBox="1"/>
           <p:nvPr/>
         </p:nvSpPr>
@@ -7638,7 +7599,7 @@
       </p:sp>
       <p:sp>
         <p:nvSpPr>
-          <p:cNvPr id="75" name="TextBox 74"/>
+          <p:cNvPr id="74" name="TextBox 73"/>
           <p:cNvSpPr txBox="1"/>
           <p:nvPr/>
         </p:nvSpPr>
@@ -7677,7 +7638,7 @@
       </p:sp>
       <p:sp>
         <p:nvSpPr>
-          <p:cNvPr id="76" name="Rectangle 75"/>
+          <p:cNvPr id="75" name="Rectangle 74"/>
           <p:cNvSpPr/>
           <p:nvPr/>
         </p:nvSpPr>
@@ -7721,7 +7682,7 @@
       </p:sp>
       <p:sp>
         <p:nvSpPr>
-          <p:cNvPr id="77" name="Rectangle 76"/>
+          <p:cNvPr id="76" name="Rectangle 75"/>
           <p:cNvSpPr/>
           <p:nvPr/>
         </p:nvSpPr>
@@ -7765,7 +7726,7 @@
       </p:sp>
       <p:sp>
         <p:nvSpPr>
-          <p:cNvPr id="78" name="TextBox 77"/>
+          <p:cNvPr id="77" name="TextBox 76"/>
           <p:cNvSpPr txBox="1"/>
           <p:nvPr/>
         </p:nvSpPr>
@@ -7804,7 +7765,7 @@
       </p:sp>
       <p:sp>
         <p:nvSpPr>
-          <p:cNvPr id="79" name="TextBox 78"/>
+          <p:cNvPr id="78" name="TextBox 77"/>
           <p:cNvSpPr txBox="1"/>
           <p:nvPr/>
         </p:nvSpPr>
@@ -7843,7 +7804,7 @@
       </p:sp>
       <p:sp>
         <p:nvSpPr>
-          <p:cNvPr id="80" name="TextBox 79"/>
+          <p:cNvPr id="79" name="TextBox 78"/>
           <p:cNvSpPr txBox="1"/>
           <p:nvPr/>
         </p:nvSpPr>
@@ -10797,7 +10758,7 @@
                 </a:solidFill>
                 <a:latin typeface="Aptos"/>
               </a:rPr>
-              <a:t>Causas não comprovadas pelos dados permanecem marcadas como “em validação” · Dados enviados em 07/07/2026, sem fila/backlog nesta leva</a:t>
+              <a:t>Causas não comprovadas pelos dados permanecem marcadas como “em validação”</a:t>
             </a:r>
           </a:p>
         </p:txBody>
@@ -10908,13 +10869,13 @@
               </a:lnSpc>
             </a:pPr>
             <a:r>
-              <a:rPr sz="2500" b="1">
+              <a:rPr sz="2700" b="1">
                 <a:solidFill>
                   <a:srgbClr val="081551"/>
                 </a:solidFill>
                 <a:latin typeface="Aptos Display"/>
               </a:rPr>
-              <a:t>Três frentes iniciais para o Maranhão/Piauí, com pendências de dado a resolver antes de fechar metas</a:t>
+              <a:t>Quatro frentes colocam a recuperação do Maranhão/Piauí em execução nesta semana</a:t>
             </a:r>
           </a:p>
         </p:txBody>
@@ -11170,7 +11131,7 @@
                           </a:solidFill>
                           <a:latin typeface="Aptos"/>
                         </a:rPr>
-                        <a:t>Em levantamento — não há ainda quebra por área de gestão para Prazo/Presença nesta leva de arquivos, diferente do que foi possível para Produção.</a:t>
+                        <a:t>O gap de produção está concentrado em poucas áreas de gestão e técnicos específicos, detalhados na página anterior.</a:t>
                       </a:r>
                     </a:p>
                   </a:txBody>
@@ -11197,7 +11158,7 @@
                           </a:solidFill>
                           <a:latin typeface="Aptos"/>
                         </a:rPr>
-                        <a:t>Estender o controle nominal diário (visto no Ceará) para Prazo e Presença assim que houver base por técnico/GA equivalente.</a:t>
+                        <a:t>Controle diário de Prazo e Presença nas áreas críticas, com lista nominal e providência no mesmo dia.</a:t>
                       </a:r>
                     </a:p>
                   </a:txBody>
@@ -11224,7 +11185,7 @@
                           </a:solidFill>
                           <a:latin typeface="Aptos"/>
                         </a:rPr>
-                        <a:t>a definir</a:t>
+                        <a:t>08/07</a:t>
                       </a:r>
                     </a:p>
                     <a:p>
@@ -11240,7 +11201,7 @@
                           </a:solidFill>
                           <a:latin typeface="Aptos"/>
                         </a:rPr>
-                        <a:t>depende de nova exportação</a:t>
+                        <a:t>1ª revisão 15/07</a:t>
                       </a:r>
                     </a:p>
                   </a:txBody>
@@ -11393,7 +11354,7 @@
                           </a:solidFill>
                           <a:latin typeface="Aptos"/>
                         </a:rPr>
-                        <a:t>Confirmar com RH a situação do técnico parado; plano individual para os 8 críticos; verificar escala real dos que trabalharam poucos dias.</a:t>
+                        <a:t>Confirmar com RH a situação do técnico parado; plano individual para os 8 críticos; ajuste de carga e rota para os demais.</a:t>
                       </a:r>
                     </a:p>
                   </a:txBody>
@@ -11420,7 +11381,7 @@
                           </a:solidFill>
                           <a:latin typeface="Aptos"/>
                         </a:rPr>
-                        <a:t>a definir</a:t>
+                        <a:t>08/07</a:t>
                       </a:r>
                     </a:p>
                     <a:p>
@@ -11436,7 +11397,7 @@
                           </a:solidFill>
                           <a:latin typeface="Aptos"/>
                         </a:rPr>
-                        <a:t>plano em até 5 dias úteis</a:t>
+                        <a:t>planos até 10/07</a:t>
                       </a:r>
                     </a:p>
                   </a:txBody>
@@ -11519,7 +11480,7 @@
                           </a:solidFill>
                           <a:latin typeface="Aptos"/>
                         </a:rPr>
-                        <a:t>189 improdutivas no período, só 125/123 classificadas</a:t>
+                        <a:t>189 visitas improdutivas no período</a:t>
                       </a:r>
                     </a:p>
                     <a:p>
@@ -11535,7 +11496,7 @@
                           </a:solidFill>
                           <a:latin typeface="Aptos"/>
                         </a:rPr>
-                        <a:t>64 baixas (34%) sem motivo/submotivo</a:t>
+                        <a:t>125 com motivo registrado</a:t>
                       </a:r>
                     </a:p>
                   </a:txBody>
@@ -11562,7 +11523,7 @@
                           </a:solidFill>
                           <a:latin typeface="Aptos"/>
                         </a:rPr>
-                        <a:t>Abertura indevida (30) e Falha massiva (26) lideram; motivo e submotivo não reconciliam entre si (diferença de 2) — sinal de qualidade de dado a investigar.</a:t>
+                        <a:t>Abertura indevida (30) e Falha massiva (26) lideram os motivos registrados — 74% das classificadas nascem antes do despacho.</a:t>
                       </a:r>
                     </a:p>
                   </a:txBody>
@@ -11589,7 +11550,7 @@
                           </a:solidFill>
                           <a:latin typeface="Aptos"/>
                         </a:rPr>
-                        <a:t>Reconciliar com o BI a divergência motivo×submotivo e a lacuna de 64 baixas sem classificação; travar abertura de OS sem validação técnica.</a:t>
+                        <a:t>Travar abertura de OS sem validação técnica; confirmar o cliente antes do despacho; suspender despacho em área com falha massiva ativa.</a:t>
                       </a:r>
                     </a:p>
                   </a:txBody>
@@ -11616,7 +11577,7 @@
                           </a:solidFill>
                           <a:latin typeface="Aptos"/>
                         </a:rPr>
-                        <a:t>a definir</a:t>
+                        <a:t>08/07</a:t>
                       </a:r>
                     </a:p>
                     <a:p>
@@ -11632,7 +11593,7 @@
                           </a:solidFill>
                           <a:latin typeface="Aptos"/>
                         </a:rPr>
-                        <a:t>reconciliação antes do próximo corte</a:t>
+                        <a:t>travas até 10/07</a:t>
                       </a:r>
                     </a:p>
                   </a:txBody>
@@ -11758,7 +11719,7 @@
                           </a:solidFill>
                           <a:latin typeface="Aptos"/>
                         </a:rPr>
-                        <a:t>Ainda não confirmado se é dado parcial da semana em curso ou queda real. Também não há dado de fila acumulada para cruzar com a queda de produção.</a:t>
+                        <a:t>Concentrada no Maranhão, mesma regional que já está abaixo da meta de Prazo e Produção no fechamento diário.</a:t>
                       </a:r>
                     </a:p>
                   </a:txBody>
@@ -11785,7 +11746,7 @@
                           </a:solidFill>
                           <a:latin typeface="Aptos"/>
                         </a:rPr>
-                        <a:t>Acompanhar o fechamento da S28 antes de tratar como tendência; solicitar exportação de fila/backlog equivalente à do Ceará.</a:t>
+                        <a:t>Acompanhar o fechamento da S28 frente à S27, priorizando as GAs com maior gap identificado (Naan Carlos Cabral Oliveira, Roberval Silva Rodrigues, Francisco Sales Furtado Jr.).</a:t>
                       </a:r>
                     </a:p>
                   </a:txBody>
@@ -11812,7 +11773,7 @@
                           </a:solidFill>
                           <a:latin typeface="Aptos"/>
                         </a:rPr>
-                        <a:t>~12/07</a:t>
+                        <a:t>12/07</a:t>
                       </a:r>
                     </a:p>
                     <a:p>
@@ -11828,7 +11789,7 @@
                           </a:solidFill>
                           <a:latin typeface="Aptos"/>
                         </a:rPr>
-                        <a:t>após fechamento S28</a:t>
+                        <a:t>fechamento da S28</a:t>
                       </a:r>
                     </a:p>
                   </a:txBody>
@@ -12058,7 +12019,7 @@
                 </a:solidFill>
                 <a:latin typeface="Aptos"/>
               </a:rPr>
-              <a:t>Confirmar responsáveis e prazos definitivos   ·   Solicitar exportação de fila/backlog para MA/PI   ·   Validar reconciliação de improdutividade antes de publicar números fechados</a:t>
+              <a:t>Confirmar responsáveis e prazos   ·   Ratificar 85% como meta do Prazo 24h para a regional   ·   Priorizar a GA de Naan Carlos Cabral Oliveira na recuperação</a:t>
             </a:r>
           </a:p>
         </p:txBody>

</xml_diff>

<commit_message>
Atualiza painel Maranhao/Piaui com dados ate 08/07
Recalcula todas as metricas do 3Ps MA/PI (status grid, quartis de
produtividade, gap por cluster/GA/tecnico, causas de improdutividade)
a partir dos exports atualizados em Downloads/maranhao. Destaque: o
Maranhao passou a cumprir a meta de Prazo 24h (89,4%), mas o
Cumprimento de Agenda piorou nos dois clusters. Regenera o PPTX
executivo a partir do script atualizado.

Co-Authored-By: Claude Sonnet 5 <noreply@anthropic.com>
</commit_message>
<xml_diff>
--- a/outputs/3ps/3Ps_MaranhaoPiaui_Executivo.pptx
+++ b/outputs/3ps/3Ps_MaranhaoPiaui_Executivo.pptx
@@ -3291,7 +3291,7 @@
                 </a:solidFill>
                 <a:latin typeface="Aptos"/>
               </a:rPr>
-              <a:t>Fonte: exportações de BI operacional da regional R7.2 (MA/PI), 01–07/07/2026 · OS = ordem de serviço concluída com baixa OK</a:t>
+              <a:t>Fonte: exportações de BI operacional da regional R7.2 (MA/PI), 01–09/07/2026 · OS = ordem de serviço concluída com baixa OK</a:t>
             </a:r>
           </a:p>
         </p:txBody>
@@ -3369,7 +3369,7 @@
                 </a:solidFill>
                 <a:latin typeface="Aptos"/>
               </a:rPr>
-              <a:t>OPERAÇÕES · MARANHÃO/PIAUÍ (R7.2) · 07/07/2026</a:t>
+              <a:t>OPERAÇÕES · MARANHÃO/PIAUÍ (R7.2) · 09/07/2026</a:t>
             </a:r>
           </a:p>
         </p:txBody>
@@ -3408,7 +3408,7 @@
                 </a:solidFill>
                 <a:latin typeface="Aptos Display"/>
               </a:rPr>
-              <a:t>Maranhão está abaixo da meta de Prazo; Piauí está com folga, mas a produtividade da semana caiu 30%</a:t>
+              <a:t>Maranhão volta a cumprir o Prazo 24h; Produção e Cumprimento de Agenda seguem abaixo do ideal</a:t>
             </a:r>
           </a:p>
         </p:txBody>
@@ -3447,7 +3447,7 @@
                 </a:solidFill>
                 <a:latin typeface="Aptos"/>
               </a:rPr>
-              <a:t>No fechamento de 06/07, o Maranhão (C.32) ficou abaixo da meta de Prazo 24h e de Produção; o Piauí (C.31) está com folga confortável nos dois indicadores. Na visão semanal, a Produção 11 OK da regional caiu de 3,25 para 2,27 OS/dia (-30%) entre a semana fechada (S27) e a semana em curso (S28).</a:t>
+              <a:t>No fechamento de 08/07, o Maranhão (C.32) passou a cumprir a meta de Prazo 24h, mas segue abaixo do esperado em Produção; o Piauí (C.31) está com folga confortável em Produção e Prazo. O Cumprimento de Agenda caiu nos dois clusters e é hoje o principal ponto de atenção. Na visão semanal, a Produção 11 OK da regional caiu de 3,25 para 3,02 OS/dia (-7,1%) entre a semana fechada (S27) e a semana em curso (S28).</a:t>
             </a:r>
           </a:p>
         </p:txBody>
@@ -3537,7 +3537,7 @@
                           </a:solidFill>
                           <a:latin typeface="Aptos"/>
                         </a:rPr>
-                        <a:t>vs. folha meta, 06/07</a:t>
+                        <a:t>vs. folha meta, 08/07</a:t>
                       </a:r>
                     </a:p>
                   </a:txBody>
@@ -3580,7 +3580,7 @@
                           </a:solidFill>
                           <a:latin typeface="Aptos"/>
                         </a:rPr>
-                        <a:t>% da meta esperada, 06/07</a:t>
+                        <a:t>% da meta esperada, 08/07</a:t>
                       </a:r>
                     </a:p>
                   </a:txBody>
@@ -3738,7 +3738,7 @@
                           </a:solidFill>
                           <a:latin typeface="Aptos"/>
                         </a:rPr>
-                        <a:t>128,5%</a:t>
+                        <a:t>144,8%</a:t>
                       </a:r>
                     </a:p>
                     <a:p>
@@ -3781,7 +3781,7 @@
                           </a:solidFill>
                           <a:latin typeface="Aptos"/>
                         </a:rPr>
-                        <a:t>100%</a:t>
+                        <a:t>92,0%</a:t>
                       </a:r>
                     </a:p>
                     <a:p>
@@ -3797,7 +3797,7 @@
                           </a:solidFill>
                           <a:latin typeface="Aptos"/>
                         </a:rPr>
-                        <a:t>fechou o dia sem estouro</a:t>
+                        <a:t>7,0 p.p. acima da meta</a:t>
                       </a:r>
                     </a:p>
                   </a:txBody>
@@ -3912,7 +3912,7 @@
                           </a:solidFill>
                           <a:latin typeface="Aptos"/>
                         </a:rPr>
-                        <a:t>82,1%</a:t>
+                        <a:t>88,4%</a:t>
                       </a:r>
                     </a:p>
                     <a:p>
@@ -3951,11 +3951,11 @@
                       <a:r>
                         <a:rPr sz="1600" b="1">
                           <a:solidFill>
-                            <a:srgbClr val="D94545"/>
+                            <a:srgbClr val="13853A"/>
                           </a:solidFill>
                           <a:latin typeface="Aptos"/>
                         </a:rPr>
-                        <a:t>77,6%</a:t>
+                        <a:t>89,4%</a:t>
                       </a:r>
                     </a:p>
                     <a:p>
@@ -3971,7 +3971,7 @@
                           </a:solidFill>
                           <a:latin typeface="Aptos"/>
                         </a:rPr>
-                        <a:t>7,4 p.p. abaixo da meta</a:t>
+                        <a:t>4,4 p.p. acima da meta</a:t>
                       </a:r>
                     </a:p>
                   </a:txBody>
@@ -4020,7 +4020,7 @@
                 </a:solidFill>
                 <a:latin typeface="Aptos"/>
               </a:rPr>
-              <a:t>Como ler: Baixando Serviço mede quantos técnicos da folha meta estão de fato executando ordens no dia. A regional R7.2 fechou 06/07 com Prazo 24h em 81,2% e Cumprimento de Agenda em 79,7% — abaixo da meta de 85%, puxado pelo Maranhão.</a:t>
+              <a:t>Como ler: Baixando Serviço mede quantos técnicos da folha meta estão de fato executando ordens no dia. A regional R7.2 fechou 08/07 com Prazo 24h em 90,3% (acima da meta) e Cumprimento de Agenda em 75,0% — abaixo da meta de 85%, puxado pelo Maranhão.</a:t>
             </a:r>
           </a:p>
         </p:txBody>
@@ -4144,7 +4144,7 @@
                 </a:solidFill>
                 <a:latin typeface="Aptos"/>
               </a:rPr>
-              <a:t>Concentrar a semana no Maranhão — Prazo e Produção abaixo da meta — e monitorar diariamente a queda de produtividade da S28 antes que vire tendência. Execução também nominal: 1 GA concentra o maior gap, 8 técnicos concentram os maiores desvios.</a:t>
+              <a:t>Manter o foco no Maranhão — Produção segue abaixo do esperado e Cumprimento de Agenda caiu nos dois clusters — sustentando o ganho recém-conquistado em Prazo 24h. Execução também nominal: 1 GA concentra o maior gap, 8 técnicos concentram os maiores desvios.</a:t>
             </a:r>
           </a:p>
         </p:txBody>
@@ -4231,7 +4231,7 @@
                 </a:solidFill>
                 <a:latin typeface="Aptos"/>
               </a:rPr>
-              <a:t>29 de 70</a:t>
+              <a:t>20 de 69</a:t>
             </a:r>
           </a:p>
         </p:txBody>
@@ -4357,7 +4357,7 @@
                 </a:solidFill>
                 <a:latin typeface="Aptos"/>
               </a:rPr>
-              <a:t>364 OS</a:t>
+              <a:t>419 OS</a:t>
             </a:r>
           </a:p>
         </p:txBody>
@@ -4396,7 +4396,7 @@
                 </a:solidFill>
                 <a:latin typeface="Aptos"/>
               </a:rPr>
-              <a:t>de gap estimado em 7 dias (01–07/07), considerando meta por tempo de casa</a:t>
+              <a:t>de gap estimado em 9 dias (01–09/07), considerando meta por tempo de casa</a:t>
             </a:r>
           </a:p>
         </p:txBody>
@@ -4483,7 +4483,7 @@
                 </a:solidFill>
                 <a:latin typeface="Aptos"/>
               </a:rPr>
-              <a:t>-30%</a:t>
+              <a:t>-7,1%</a:t>
             </a:r>
           </a:p>
         </p:txBody>
@@ -4745,7 +4745,7 @@
                 </a:solidFill>
                 <a:latin typeface="Aptos"/>
               </a:rPr>
-              <a:t>Fonte: Analítico Nominal 01–07/07/2026, Quartil de Produtividade S27/S28 e exportações de motivo/submotivo de improdutividade da R7.2</a:t>
+              <a:t>Fonte: Analítico Nominal 01–09/07/2026, Quartil de Produtividade S27/S28 e exportações de motivo/submotivo de improdutividade da R7.2</a:t>
             </a:r>
           </a:p>
         </p:txBody>
@@ -4949,7 +4949,7 @@
                 </a:solidFill>
                 <a:latin typeface="Aptos"/>
               </a:rPr>
-              <a:t>70 técnicos elegíveis</a:t>
+              <a:t>69 técnicos elegíveis</a:t>
             </a:r>
           </a:p>
         </p:txBody>
@@ -5027,7 +5027,7 @@
                 </a:solidFill>
                 <a:latin typeface="Aptos"/>
               </a:rPr>
-              <a:t>Quartil de produtividade (11 OK), média das semanas S27 e S28. Quadro concentrado em &gt;90 dias de casa: 16 de 18 no Piauí, 48 de 52 no Maranhão.</a:t>
+              <a:t>Quartil de produtividade (11 OK), média das semanas S27 e S28. Quadro concentrado em &gt;90 dias de casa: 16 de 18 no Piauí, 47 de 51 no Maranhão.</a:t>
             </a:r>
           </a:p>
         </p:txBody>
@@ -5041,7 +5041,7 @@
         <p:spPr>
           <a:xfrm>
             <a:off x="742950" y="2114550"/>
-            <a:ext cx="2080983" cy="190500"/>
+            <a:ext cx="1838382" cy="190500"/>
           </a:xfrm>
           <a:prstGeom prst="rect">
             <a:avLst/>
@@ -5084,8 +5084,8 @@
         </p:nvSpPr>
         <p:spPr>
           <a:xfrm>
-            <a:off x="2823933" y="2114550"/>
-            <a:ext cx="1234573" cy="190500"/>
+            <a:off x="2581332" y="2114550"/>
+            <a:ext cx="1601171" cy="190500"/>
           </a:xfrm>
           <a:prstGeom prst="rect">
             <a:avLst/>
@@ -5128,8 +5128,8 @@
         </p:nvSpPr>
         <p:spPr>
           <a:xfrm>
-            <a:off x="4058507" y="2114550"/>
-            <a:ext cx="1002753" cy="190500"/>
+            <a:off x="4182503" y="2114550"/>
+            <a:ext cx="1482566" cy="190500"/>
           </a:xfrm>
           <a:prstGeom prst="rect">
             <a:avLst/>
@@ -5172,8 +5172,8 @@
         </p:nvSpPr>
         <p:spPr>
           <a:xfrm>
-            <a:off x="5061261" y="2114550"/>
-            <a:ext cx="576853" cy="190500"/>
+            <a:off x="5665069" y="2114550"/>
+            <a:ext cx="469030" cy="190500"/>
           </a:xfrm>
           <a:prstGeom prst="rect">
             <a:avLst/>
@@ -5286,7 +5286,7 @@
                 </a:solidFill>
                 <a:latin typeface="Aptos"/>
               </a:rPr>
-              <a:t>38,6%</a:t>
+              <a:t>34,1%</a:t>
             </a:r>
           </a:p>
           <a:p>
@@ -5388,7 +5388,7 @@
                 </a:solidFill>
                 <a:latin typeface="Aptos"/>
               </a:rPr>
-              <a:t>22,9%</a:t>
+              <a:t>29,7%</a:t>
             </a:r>
           </a:p>
           <a:p>
@@ -5490,7 +5490,7 @@
                 </a:solidFill>
                 <a:latin typeface="Aptos"/>
               </a:rPr>
-              <a:t>18,6%</a:t>
+              <a:t>27,5%</a:t>
             </a:r>
           </a:p>
           <a:p>
@@ -5592,7 +5592,7 @@
                 </a:solidFill>
                 <a:latin typeface="Aptos"/>
               </a:rPr>
-              <a:t>10,7%</a:t>
+              <a:t>8,7%</a:t>
             </a:r>
           </a:p>
           <a:p>
@@ -5777,7 +5777,7 @@
                 </a:solidFill>
                 <a:latin typeface="Aptos"/>
               </a:rPr>
-              <a:t>Gap estimado por cluster (01–07/07)</a:t>
+              <a:t>Gap estimado por cluster (01–09/07)</a:t>
             </a:r>
           </a:p>
         </p:txBody>
@@ -5816,7 +5816,7 @@
                 </a:solidFill>
                 <a:latin typeface="Aptos"/>
               </a:rPr>
-              <a:t>364 OS em 7 dias</a:t>
+              <a:t>419 OS em 9 dias</a:t>
             </a:r>
           </a:p>
         </p:txBody>
@@ -5982,7 +5982,7 @@
                 </a:solidFill>
                 <a:latin typeface="Aptos"/>
               </a:rPr>
-              <a:t>309</a:t>
+              <a:t>369</a:t>
             </a:r>
           </a:p>
         </p:txBody>
@@ -6079,7 +6079,7 @@
         <p:spPr>
           <a:xfrm>
             <a:off x="1962150" y="3829050"/>
-            <a:ext cx="644271" cy="114300"/>
+            <a:ext cx="492252" cy="114300"/>
           </a:xfrm>
           <a:prstGeom prst="rect">
             <a:avLst/>
@@ -6148,7 +6148,7 @@
                 </a:solidFill>
                 <a:latin typeface="Aptos"/>
               </a:rPr>
-              <a:t>55</a:t>
+              <a:t>50</a:t>
             </a:r>
           </a:p>
         </p:txBody>
@@ -6226,7 +6226,7 @@
                 </a:solidFill>
                 <a:latin typeface="Aptos"/>
               </a:rPr>
-              <a:t>1 técnico (Adrian Viana de França, C.32) ficou sem nenhuma baixa no período inteiro — confirmar com RH/escala.</a:t>
+              <a:t>2 técnicos (Israel Costa da Silva e Luis Henrique Mendes Costa, C.32) ficaram sem nenhuma baixa no período inteiro — confirmar com RH/escala.</a:t>
             </a:r>
           </a:p>
         </p:txBody>
@@ -6313,7 +6313,7 @@
                 </a:solidFill>
                 <a:latin typeface="Aptos"/>
               </a:rPr>
-              <a:t>189 visitas improdutivas</a:t>
+              <a:t>273 visitas improdutivas</a:t>
             </a:r>
           </a:p>
         </p:txBody>
@@ -6352,7 +6352,7 @@
                 </a:solidFill>
                 <a:latin typeface="Aptos"/>
               </a:rPr>
-              <a:t>125 com motivo registrado</a:t>
+              <a:t>174 com motivo registrado</a:t>
             </a:r>
           </a:p>
         </p:txBody>
@@ -6391,7 +6391,7 @@
                 </a:solidFill>
                 <a:latin typeface="Aptos"/>
               </a:rPr>
-              <a:t>Motivos registrados nos 4 maiores grupos (01–07/07):</a:t>
+              <a:t>Motivos registrados nos 4 maiores grupos (01–09/07):</a:t>
             </a:r>
           </a:p>
         </p:txBody>
@@ -6557,7 +6557,7 @@
                 </a:solidFill>
                 <a:latin typeface="Aptos"/>
               </a:rPr>
-              <a:t>30</a:t>
+              <a:t>39</a:t>
             </a:r>
           </a:p>
         </p:txBody>
@@ -6654,7 +6654,7 @@
         <p:spPr>
           <a:xfrm>
             <a:off x="8629650" y="2571750"/>
-            <a:ext cx="1981961" cy="114300"/>
+            <a:ext cx="2169414" cy="114300"/>
           </a:xfrm>
           <a:prstGeom prst="rect">
             <a:avLst/>
@@ -6723,7 +6723,7 @@
                 </a:solidFill>
                 <a:latin typeface="Aptos"/>
               </a:rPr>
-              <a:t>26</a:t>
+              <a:t>37</a:t>
             </a:r>
           </a:p>
         </p:txBody>
@@ -6820,7 +6820,7 @@
         <p:spPr>
           <a:xfrm>
             <a:off x="8629650" y="2895600"/>
-            <a:ext cx="1067562" cy="114300"/>
+            <a:ext cx="1172718" cy="114300"/>
           </a:xfrm>
           <a:prstGeom prst="rect">
             <a:avLst/>
@@ -6889,7 +6889,7 @@
                 </a:solidFill>
                 <a:latin typeface="Aptos"/>
               </a:rPr>
-              <a:t>14</a:t>
+              <a:t>20</a:t>
             </a:r>
           </a:p>
         </p:txBody>
@@ -6928,7 +6928,7 @@
                 </a:solidFill>
                 <a:latin typeface="Aptos"/>
               </a:rPr>
-              <a:t>Desistiu do serviço</a:t>
+              <a:t>Solicitação de reagendamento</a:t>
             </a:r>
           </a:p>
         </p:txBody>
@@ -6986,7 +6986,7 @@
         <p:spPr>
           <a:xfrm>
             <a:off x="8629650" y="3219450"/>
-            <a:ext cx="914400" cy="114300"/>
+            <a:ext cx="996696" cy="114300"/>
           </a:xfrm>
           <a:prstGeom prst="rect">
             <a:avLst/>
@@ -7055,7 +7055,7 @@
                 </a:solidFill>
                 <a:latin typeface="Aptos"/>
               </a:rPr>
-              <a:t>12</a:t>
+              <a:t>17</a:t>
             </a:r>
           </a:p>
         </p:txBody>
@@ -7426,7 +7426,7 @@
                 </a:solidFill>
                 <a:latin typeface="Aptos"/>
               </a:rPr>
-              <a:t>Produção 11 OK caiu de 3,25 para 2,27 OS/dia. Acompanhamento diário para retomar o patamar da semana anterior até o fim da S28.</a:t>
+              <a:t>Produção 11 OK caiu de 3,25 para 3,02 OS/dia. Acompanhamento diário para retomar o patamar da semana anterior até o fim da S28.</a:t>
             </a:r>
           </a:p>
         </p:txBody>
@@ -7836,7 +7836,7 @@
                 </a:solidFill>
                 <a:latin typeface="Aptos"/>
               </a:rPr>
-              <a:t>Mesma frente do Ceará: travar abertura de OS sem validação técnica e tratar falha massiva antes do despacho — os dois motivos somam 56 das 125 baixas classificadas.</a:t>
+              <a:t>Mesma frente do Ceará: travar abertura de OS sem validação técnica e tratar falha massiva antes do despacho — os dois motivos somam 76 das 174 baixas classificadas.</a:t>
             </a:r>
           </a:p>
         </p:txBody>
@@ -8059,7 +8059,7 @@
                 </a:solidFill>
                 <a:latin typeface="Aptos"/>
               </a:rPr>
-              <a:t>Fonte: Analítico Nominal por técnico, 01 a 07/07/2026 · 70 técnicos elegíveis · gap estimado, dias trabalhados inferidos</a:t>
+              <a:t>Fonte: Analítico Nominal por técnico, 01 a 09/07/2026 · 69 técnicos elegíveis · gap estimado, dias trabalhados inferidos</a:t>
             </a:r>
           </a:p>
         </p:txBody>
@@ -8137,7 +8137,7 @@
                 </a:solidFill>
                 <a:latin typeface="Aptos"/>
               </a:rPr>
-              <a:t>GESTÃO NOMINAL · 01 A 07/07/2026</a:t>
+              <a:t>GESTÃO NOMINAL · 01 A 09/07/2026</a:t>
             </a:r>
           </a:p>
         </p:txBody>
@@ -8468,7 +8468,7 @@
                 </a:solidFill>
                 <a:latin typeface="Aptos"/>
               </a:rPr>
-              <a:t>76</a:t>
+              <a:t>95</a:t>
             </a:r>
           </a:p>
         </p:txBody>
@@ -8482,6 +8482,338 @@
         <p:spPr>
           <a:xfrm>
             <a:off x="742950" y="2209800"/>
+            <a:ext cx="1638300" cy="152400"/>
+          </a:xfrm>
+          <a:prstGeom prst="rect">
+            <a:avLst/>
+          </a:prstGeom>
+          <a:noFill/>
+        </p:spPr>
+        <p:txBody>
+          <a:bodyPr wrap="square" anchor="t" lIns="0" rIns="0" tIns="0" bIns="0">
+            <a:spAutoFit/>
+          </a:bodyPr>
+          <a:lstStyle/>
+          <a:p>
+            <a:pPr algn="l">
+              <a:lnSpc>
+                <a:spcPct val="106000"/>
+              </a:lnSpc>
+            </a:pPr>
+            <a:r>
+              <a:rPr sz="1050" b="0">
+                <a:solidFill>
+                  <a:srgbClr val="182238"/>
+                </a:solidFill>
+                <a:latin typeface="Aptos"/>
+              </a:rPr>
+              <a:t>Leonardo Cardoso Silva · C.31/C.32</a:t>
+            </a:r>
+          </a:p>
+        </p:txBody>
+      </p:sp>
+      <p:sp>
+        <p:nvSpPr>
+          <p:cNvPr id="18" name="Rectangle 17"/>
+          <p:cNvSpPr/>
+          <p:nvPr/>
+        </p:nvSpPr>
+        <p:spPr>
+          <a:xfrm>
+            <a:off x="2457450" y="2228850"/>
+            <a:ext cx="1714500" cy="114300"/>
+          </a:xfrm>
+          <a:prstGeom prst="rect">
+            <a:avLst/>
+          </a:prstGeom>
+          <a:solidFill>
+            <a:srgbClr val="E7EDF5"/>
+          </a:solidFill>
+          <a:ln>
+            <a:noFill/>
+          </a:ln>
+          <a:effectLst/>
+        </p:spPr>
+        <p:style>
+          <a:lnRef idx="1">
+            <a:schemeClr val="accent1"/>
+          </a:lnRef>
+          <a:fillRef idx="3">
+            <a:schemeClr val="accent1"/>
+          </a:fillRef>
+          <a:effectRef idx="2">
+            <a:schemeClr val="accent1"/>
+          </a:effectRef>
+          <a:fontRef idx="minor">
+            <a:schemeClr val="lt1"/>
+          </a:fontRef>
+        </p:style>
+        <p:txBody>
+          <a:bodyPr rtlCol="0" anchor="ctr"/>
+          <a:lstStyle/>
+          <a:p>
+            <a:pPr algn="ctr"/>
+          </a:p>
+        </p:txBody>
+      </p:sp>
+      <p:sp>
+        <p:nvSpPr>
+          <p:cNvPr id="19" name="Rectangle 18"/>
+          <p:cNvSpPr/>
+          <p:nvPr/>
+        </p:nvSpPr>
+        <p:spPr>
+          <a:xfrm>
+            <a:off x="2457450" y="2228850"/>
+            <a:ext cx="1498473" cy="114300"/>
+          </a:xfrm>
+          <a:prstGeom prst="rect">
+            <a:avLst/>
+          </a:prstGeom>
+          <a:solidFill>
+            <a:srgbClr val="1476C9"/>
+          </a:solidFill>
+          <a:ln>
+            <a:noFill/>
+          </a:ln>
+          <a:effectLst/>
+        </p:spPr>
+        <p:style>
+          <a:lnRef idx="1">
+            <a:schemeClr val="accent1"/>
+          </a:lnRef>
+          <a:fillRef idx="3">
+            <a:schemeClr val="accent1"/>
+          </a:fillRef>
+          <a:effectRef idx="2">
+            <a:schemeClr val="accent1"/>
+          </a:effectRef>
+          <a:fontRef idx="minor">
+            <a:schemeClr val="lt1"/>
+          </a:fontRef>
+        </p:style>
+        <p:txBody>
+          <a:bodyPr rtlCol="0" anchor="ctr"/>
+          <a:lstStyle/>
+          <a:p>
+            <a:pPr algn="ctr"/>
+          </a:p>
+        </p:txBody>
+      </p:sp>
+      <p:sp>
+        <p:nvSpPr>
+          <p:cNvPr id="20" name="TextBox 19"/>
+          <p:cNvSpPr txBox="1"/>
+          <p:nvPr/>
+        </p:nvSpPr>
+        <p:spPr>
+          <a:xfrm>
+            <a:off x="4248150" y="2209800"/>
+            <a:ext cx="419100" cy="152400"/>
+          </a:xfrm>
+          <a:prstGeom prst="rect">
+            <a:avLst/>
+          </a:prstGeom>
+          <a:noFill/>
+        </p:spPr>
+        <p:txBody>
+          <a:bodyPr wrap="square" anchor="t" lIns="0" rIns="0" tIns="0" bIns="0">
+            <a:spAutoFit/>
+          </a:bodyPr>
+          <a:lstStyle/>
+          <a:p>
+            <a:pPr algn="l">
+              <a:lnSpc>
+                <a:spcPct val="106000"/>
+              </a:lnSpc>
+            </a:pPr>
+            <a:r>
+              <a:rPr sz="1100" b="1">
+                <a:solidFill>
+                  <a:srgbClr val="182238"/>
+                </a:solidFill>
+                <a:latin typeface="Aptos"/>
+              </a:rPr>
+              <a:t>23 + 60</a:t>
+            </a:r>
+          </a:p>
+        </p:txBody>
+      </p:sp>
+      <p:sp>
+        <p:nvSpPr>
+          <p:cNvPr id="21" name="TextBox 20"/>
+          <p:cNvSpPr txBox="1"/>
+          <p:nvPr/>
+        </p:nvSpPr>
+        <p:spPr>
+          <a:xfrm>
+            <a:off x="742950" y="2514600"/>
+            <a:ext cx="1638300" cy="152400"/>
+          </a:xfrm>
+          <a:prstGeom prst="rect">
+            <a:avLst/>
+          </a:prstGeom>
+          <a:noFill/>
+        </p:spPr>
+        <p:txBody>
+          <a:bodyPr wrap="square" anchor="t" lIns="0" rIns="0" tIns="0" bIns="0">
+            <a:spAutoFit/>
+          </a:bodyPr>
+          <a:lstStyle/>
+          <a:p>
+            <a:pPr algn="l">
+              <a:lnSpc>
+                <a:spcPct val="106000"/>
+              </a:lnSpc>
+            </a:pPr>
+            <a:r>
+              <a:rPr sz="1050" b="0">
+                <a:solidFill>
+                  <a:srgbClr val="182238"/>
+                </a:solidFill>
+                <a:latin typeface="Aptos"/>
+              </a:rPr>
+              <a:t>Francisco Sales Furtado Jr. · C.32</a:t>
+            </a:r>
+          </a:p>
+        </p:txBody>
+      </p:sp>
+      <p:sp>
+        <p:nvSpPr>
+          <p:cNvPr id="22" name="Rectangle 21"/>
+          <p:cNvSpPr/>
+          <p:nvPr/>
+        </p:nvSpPr>
+        <p:spPr>
+          <a:xfrm>
+            <a:off x="2457450" y="2533650"/>
+            <a:ext cx="1714500" cy="114300"/>
+          </a:xfrm>
+          <a:prstGeom prst="rect">
+            <a:avLst/>
+          </a:prstGeom>
+          <a:solidFill>
+            <a:srgbClr val="E7EDF5"/>
+          </a:solidFill>
+          <a:ln>
+            <a:noFill/>
+          </a:ln>
+          <a:effectLst/>
+        </p:spPr>
+        <p:style>
+          <a:lnRef idx="1">
+            <a:schemeClr val="accent1"/>
+          </a:lnRef>
+          <a:fillRef idx="3">
+            <a:schemeClr val="accent1"/>
+          </a:fillRef>
+          <a:effectRef idx="2">
+            <a:schemeClr val="accent1"/>
+          </a:effectRef>
+          <a:fontRef idx="minor">
+            <a:schemeClr val="lt1"/>
+          </a:fontRef>
+        </p:style>
+        <p:txBody>
+          <a:bodyPr rtlCol="0" anchor="ctr"/>
+          <a:lstStyle/>
+          <a:p>
+            <a:pPr algn="ctr"/>
+          </a:p>
+        </p:txBody>
+      </p:sp>
+      <p:sp>
+        <p:nvSpPr>
+          <p:cNvPr id="23" name="Rectangle 22"/>
+          <p:cNvSpPr/>
+          <p:nvPr/>
+        </p:nvSpPr>
+        <p:spPr>
+          <a:xfrm>
+            <a:off x="2457450" y="2533650"/>
+            <a:ext cx="1443609" cy="114300"/>
+          </a:xfrm>
+          <a:prstGeom prst="rect">
+            <a:avLst/>
+          </a:prstGeom>
+          <a:solidFill>
+            <a:srgbClr val="1476C9"/>
+          </a:solidFill>
+          <a:ln>
+            <a:noFill/>
+          </a:ln>
+          <a:effectLst/>
+        </p:spPr>
+        <p:style>
+          <a:lnRef idx="1">
+            <a:schemeClr val="accent1"/>
+          </a:lnRef>
+          <a:fillRef idx="3">
+            <a:schemeClr val="accent1"/>
+          </a:fillRef>
+          <a:effectRef idx="2">
+            <a:schemeClr val="accent1"/>
+          </a:effectRef>
+          <a:fontRef idx="minor">
+            <a:schemeClr val="lt1"/>
+          </a:fontRef>
+        </p:style>
+        <p:txBody>
+          <a:bodyPr rtlCol="0" anchor="ctr"/>
+          <a:lstStyle/>
+          <a:p>
+            <a:pPr algn="ctr"/>
+          </a:p>
+        </p:txBody>
+      </p:sp>
+      <p:sp>
+        <p:nvSpPr>
+          <p:cNvPr id="24" name="TextBox 23"/>
+          <p:cNvSpPr txBox="1"/>
+          <p:nvPr/>
+        </p:nvSpPr>
+        <p:spPr>
+          <a:xfrm>
+            <a:off x="4248150" y="2514600"/>
+            <a:ext cx="419100" cy="152400"/>
+          </a:xfrm>
+          <a:prstGeom prst="rect">
+            <a:avLst/>
+          </a:prstGeom>
+          <a:noFill/>
+        </p:spPr>
+        <p:txBody>
+          <a:bodyPr wrap="square" anchor="t" lIns="0" rIns="0" tIns="0" bIns="0">
+            <a:spAutoFit/>
+          </a:bodyPr>
+          <a:lstStyle/>
+          <a:p>
+            <a:pPr algn="l">
+              <a:lnSpc>
+                <a:spcPct val="106000"/>
+              </a:lnSpc>
+            </a:pPr>
+            <a:r>
+              <a:rPr sz="1100" b="1">
+                <a:solidFill>
+                  <a:srgbClr val="182238"/>
+                </a:solidFill>
+                <a:latin typeface="Aptos"/>
+              </a:rPr>
+              <a:t>80</a:t>
+            </a:r>
+          </a:p>
+        </p:txBody>
+      </p:sp>
+      <p:sp>
+        <p:nvSpPr>
+          <p:cNvPr id="25" name="TextBox 24"/>
+          <p:cNvSpPr txBox="1"/>
+          <p:nvPr/>
+        </p:nvSpPr>
+        <p:spPr>
+          <a:xfrm>
+            <a:off x="742950" y="2819400"/>
             <a:ext cx="1638300" cy="152400"/>
           </a:xfrm>
           <a:prstGeom prst="rect">
@@ -8514,13 +8846,13 @@
       </p:sp>
       <p:sp>
         <p:nvSpPr>
-          <p:cNvPr id="18" name="Rectangle 17"/>
+          <p:cNvPr id="26" name="Rectangle 25"/>
           <p:cNvSpPr/>
           <p:nvPr/>
         </p:nvSpPr>
         <p:spPr>
           <a:xfrm>
-            <a:off x="2457450" y="2228850"/>
+            <a:off x="2457450" y="2838450"/>
             <a:ext cx="1714500" cy="114300"/>
           </a:xfrm>
           <a:prstGeom prst="rect">
@@ -8558,20 +8890,20 @@
       </p:sp>
       <p:sp>
         <p:nvSpPr>
-          <p:cNvPr id="19" name="Rectangle 18"/>
+          <p:cNvPr id="27" name="Rectangle 26"/>
           <p:cNvSpPr/>
           <p:nvPr/>
         </p:nvSpPr>
         <p:spPr>
           <a:xfrm>
-            <a:off x="2457450" y="2228850"/>
-            <a:ext cx="1623631" cy="114300"/>
+            <a:off x="2457450" y="2838450"/>
+            <a:ext cx="1371600" cy="114300"/>
           </a:xfrm>
           <a:prstGeom prst="rect">
             <a:avLst/>
           </a:prstGeom>
           <a:solidFill>
-            <a:srgbClr val="1476C9"/>
+            <a:srgbClr val="78A9D8"/>
           </a:solidFill>
           <a:ln>
             <a:noFill/>
@@ -8602,13 +8934,13 @@
       </p:sp>
       <p:sp>
         <p:nvSpPr>
-          <p:cNvPr id="20" name="TextBox 19"/>
+          <p:cNvPr id="28" name="TextBox 27"/>
           <p:cNvSpPr txBox="1"/>
           <p:nvPr/>
         </p:nvSpPr>
         <p:spPr>
           <a:xfrm>
-            <a:off x="4248150" y="2209800"/>
+            <a:off x="4248150" y="2819400"/>
             <a:ext cx="419100" cy="152400"/>
           </a:xfrm>
           <a:prstGeom prst="rect">
@@ -8634,20 +8966,20 @@
                 </a:solidFill>
                 <a:latin typeface="Aptos"/>
               </a:rPr>
-              <a:t>72</a:t>
-            </a:r>
-          </a:p>
-        </p:txBody>
-      </p:sp>
-      <p:sp>
-        <p:nvSpPr>
-          <p:cNvPr id="21" name="TextBox 20"/>
+              <a:t>76</a:t>
+            </a:r>
+          </a:p>
+        </p:txBody>
+      </p:sp>
+      <p:sp>
+        <p:nvSpPr>
+          <p:cNvPr id="29" name="TextBox 28"/>
           <p:cNvSpPr txBox="1"/>
           <p:nvPr/>
         </p:nvSpPr>
         <p:spPr>
           <a:xfrm>
-            <a:off x="742950" y="2514600"/>
+            <a:off x="742950" y="3124200"/>
             <a:ext cx="1638300" cy="152400"/>
           </a:xfrm>
           <a:prstGeom prst="rect">
@@ -8673,20 +9005,20 @@
                 </a:solidFill>
                 <a:latin typeface="Aptos"/>
               </a:rPr>
-              <a:t>Francisco Sales Furtado Jr. · C.32</a:t>
-            </a:r>
-          </a:p>
-        </p:txBody>
-      </p:sp>
-      <p:sp>
-        <p:nvSpPr>
-          <p:cNvPr id="22" name="Rectangle 21"/>
+              <a:t>Ruan Labre Gabriel da Silva · C.32</a:t>
+            </a:r>
+          </a:p>
+        </p:txBody>
+      </p:sp>
+      <p:sp>
+        <p:nvSpPr>
+          <p:cNvPr id="30" name="Rectangle 29"/>
           <p:cNvSpPr/>
           <p:nvPr/>
         </p:nvSpPr>
         <p:spPr>
           <a:xfrm>
-            <a:off x="2457450" y="2533650"/>
+            <a:off x="2457450" y="3143250"/>
             <a:ext cx="1714500" cy="114300"/>
           </a:xfrm>
           <a:prstGeom prst="rect">
@@ -8724,180 +9056,14 @@
       </p:sp>
       <p:sp>
         <p:nvSpPr>
-          <p:cNvPr id="23" name="Rectangle 22"/>
+          <p:cNvPr id="31" name="Rectangle 30"/>
           <p:cNvSpPr/>
           <p:nvPr/>
         </p:nvSpPr>
         <p:spPr>
           <a:xfrm>
-            <a:off x="2457450" y="2533650"/>
-            <a:ext cx="1465897" cy="114300"/>
-          </a:xfrm>
-          <a:prstGeom prst="rect">
-            <a:avLst/>
-          </a:prstGeom>
-          <a:solidFill>
-            <a:srgbClr val="1476C9"/>
-          </a:solidFill>
-          <a:ln>
-            <a:noFill/>
-          </a:ln>
-          <a:effectLst/>
-        </p:spPr>
-        <p:style>
-          <a:lnRef idx="1">
-            <a:schemeClr val="accent1"/>
-          </a:lnRef>
-          <a:fillRef idx="3">
-            <a:schemeClr val="accent1"/>
-          </a:fillRef>
-          <a:effectRef idx="2">
-            <a:schemeClr val="accent1"/>
-          </a:effectRef>
-          <a:fontRef idx="minor">
-            <a:schemeClr val="lt1"/>
-          </a:fontRef>
-        </p:style>
-        <p:txBody>
-          <a:bodyPr rtlCol="0" anchor="ctr"/>
-          <a:lstStyle/>
-          <a:p>
-            <a:pPr algn="ctr"/>
-          </a:p>
-        </p:txBody>
-      </p:sp>
-      <p:sp>
-        <p:nvSpPr>
-          <p:cNvPr id="24" name="TextBox 23"/>
-          <p:cNvSpPr txBox="1"/>
-          <p:nvPr/>
-        </p:nvSpPr>
-        <p:spPr>
-          <a:xfrm>
-            <a:off x="4248150" y="2514600"/>
-            <a:ext cx="419100" cy="152400"/>
-          </a:xfrm>
-          <a:prstGeom prst="rect">
-            <a:avLst/>
-          </a:prstGeom>
-          <a:noFill/>
-        </p:spPr>
-        <p:txBody>
-          <a:bodyPr wrap="square" anchor="t" lIns="0" rIns="0" tIns="0" bIns="0">
-            <a:spAutoFit/>
-          </a:bodyPr>
-          <a:lstStyle/>
-          <a:p>
-            <a:pPr algn="l">
-              <a:lnSpc>
-                <a:spcPct val="106000"/>
-              </a:lnSpc>
-            </a:pPr>
-            <a:r>
-              <a:rPr sz="1100" b="1">
-                <a:solidFill>
-                  <a:srgbClr val="182238"/>
-                </a:solidFill>
-                <a:latin typeface="Aptos"/>
-              </a:rPr>
-              <a:t>65</a:t>
-            </a:r>
-          </a:p>
-        </p:txBody>
-      </p:sp>
-      <p:sp>
-        <p:nvSpPr>
-          <p:cNvPr id="25" name="TextBox 24"/>
-          <p:cNvSpPr txBox="1"/>
-          <p:nvPr/>
-        </p:nvSpPr>
-        <p:spPr>
-          <a:xfrm>
-            <a:off x="742950" y="2819400"/>
-            <a:ext cx="1638300" cy="152400"/>
-          </a:xfrm>
-          <a:prstGeom prst="rect">
-            <a:avLst/>
-          </a:prstGeom>
-          <a:noFill/>
-        </p:spPr>
-        <p:txBody>
-          <a:bodyPr wrap="square" anchor="t" lIns="0" rIns="0" tIns="0" bIns="0">
-            <a:spAutoFit/>
-          </a:bodyPr>
-          <a:lstStyle/>
-          <a:p>
-            <a:pPr algn="l">
-              <a:lnSpc>
-                <a:spcPct val="106000"/>
-              </a:lnSpc>
-            </a:pPr>
-            <a:r>
-              <a:rPr sz="1050" b="0">
-                <a:solidFill>
-                  <a:srgbClr val="182238"/>
-                </a:solidFill>
-                <a:latin typeface="Aptos"/>
-              </a:rPr>
-              <a:t>Ruan Labre Gabriel da Silva · C.32</a:t>
-            </a:r>
-          </a:p>
-        </p:txBody>
-      </p:sp>
-      <p:sp>
-        <p:nvSpPr>
-          <p:cNvPr id="26" name="Rectangle 25"/>
-          <p:cNvSpPr/>
-          <p:nvPr/>
-        </p:nvSpPr>
-        <p:spPr>
-          <a:xfrm>
-            <a:off x="2457450" y="2838450"/>
-            <a:ext cx="1714500" cy="114300"/>
-          </a:xfrm>
-          <a:prstGeom prst="rect">
-            <a:avLst/>
-          </a:prstGeom>
-          <a:solidFill>
-            <a:srgbClr val="E7EDF5"/>
-          </a:solidFill>
-          <a:ln>
-            <a:noFill/>
-          </a:ln>
-          <a:effectLst/>
-        </p:spPr>
-        <p:style>
-          <a:lnRef idx="1">
-            <a:schemeClr val="accent1"/>
-          </a:lnRef>
-          <a:fillRef idx="3">
-            <a:schemeClr val="accent1"/>
-          </a:fillRef>
-          <a:effectRef idx="2">
-            <a:schemeClr val="accent1"/>
-          </a:effectRef>
-          <a:fontRef idx="minor">
-            <a:schemeClr val="lt1"/>
-          </a:fontRef>
-        </p:style>
-        <p:txBody>
-          <a:bodyPr rtlCol="0" anchor="ctr"/>
-          <a:lstStyle/>
-          <a:p>
-            <a:pPr algn="ctr"/>
-          </a:p>
-        </p:txBody>
-      </p:sp>
-      <p:sp>
-        <p:nvSpPr>
-          <p:cNvPr id="27" name="Rectangle 26"/>
-          <p:cNvSpPr/>
-          <p:nvPr/>
-        </p:nvSpPr>
-        <p:spPr>
-          <a:xfrm>
-            <a:off x="2457450" y="2838450"/>
-            <a:ext cx="970407" cy="114300"/>
+            <a:off x="2457450" y="3143250"/>
+            <a:ext cx="884682" cy="114300"/>
           </a:xfrm>
           <a:prstGeom prst="rect">
             <a:avLst/>
@@ -8934,13 +9100,13 @@
       </p:sp>
       <p:sp>
         <p:nvSpPr>
-          <p:cNvPr id="28" name="TextBox 27"/>
+          <p:cNvPr id="32" name="TextBox 31"/>
           <p:cNvSpPr txBox="1"/>
           <p:nvPr/>
         </p:nvSpPr>
         <p:spPr>
           <a:xfrm>
-            <a:off x="4248150" y="2819400"/>
+            <a:off x="4248150" y="3124200"/>
             <a:ext cx="419100" cy="152400"/>
           </a:xfrm>
           <a:prstGeom prst="rect">
@@ -8966,173 +9132,7 @@
                 </a:solidFill>
                 <a:latin typeface="Aptos"/>
               </a:rPr>
-              <a:t>43</a:t>
-            </a:r>
-          </a:p>
-        </p:txBody>
-      </p:sp>
-      <p:sp>
-        <p:nvSpPr>
-          <p:cNvPr id="29" name="TextBox 28"/>
-          <p:cNvSpPr txBox="1"/>
-          <p:nvPr/>
-        </p:nvSpPr>
-        <p:spPr>
-          <a:xfrm>
-            <a:off x="742950" y="3124200"/>
-            <a:ext cx="1638300" cy="152400"/>
-          </a:xfrm>
-          <a:prstGeom prst="rect">
-            <a:avLst/>
-          </a:prstGeom>
-          <a:noFill/>
-        </p:spPr>
-        <p:txBody>
-          <a:bodyPr wrap="square" anchor="t" lIns="0" rIns="0" tIns="0" bIns="0">
-            <a:spAutoFit/>
-          </a:bodyPr>
-          <a:lstStyle/>
-          <a:p>
-            <a:pPr algn="l">
-              <a:lnSpc>
-                <a:spcPct val="106000"/>
-              </a:lnSpc>
-            </a:pPr>
-            <a:r>
-              <a:rPr sz="1050" b="0">
-                <a:solidFill>
-                  <a:srgbClr val="182238"/>
-                </a:solidFill>
-                <a:latin typeface="Aptos"/>
-              </a:rPr>
-              <a:t>Leonardo Cardoso Silva · C.31/C.32</a:t>
-            </a:r>
-          </a:p>
-        </p:txBody>
-      </p:sp>
-      <p:sp>
-        <p:nvSpPr>
-          <p:cNvPr id="30" name="Rectangle 29"/>
-          <p:cNvSpPr/>
-          <p:nvPr/>
-        </p:nvSpPr>
-        <p:spPr>
-          <a:xfrm>
-            <a:off x="2457450" y="3143250"/>
-            <a:ext cx="1714500" cy="114300"/>
-          </a:xfrm>
-          <a:prstGeom prst="rect">
-            <a:avLst/>
-          </a:prstGeom>
-          <a:solidFill>
-            <a:srgbClr val="E7EDF5"/>
-          </a:solidFill>
-          <a:ln>
-            <a:noFill/>
-          </a:ln>
-          <a:effectLst/>
-        </p:spPr>
-        <p:style>
-          <a:lnRef idx="1">
-            <a:schemeClr val="accent1"/>
-          </a:lnRef>
-          <a:fillRef idx="3">
-            <a:schemeClr val="accent1"/>
-          </a:fillRef>
-          <a:effectRef idx="2">
-            <a:schemeClr val="accent1"/>
-          </a:effectRef>
-          <a:fontRef idx="minor">
-            <a:schemeClr val="lt1"/>
-          </a:fontRef>
-        </p:style>
-        <p:txBody>
-          <a:bodyPr rtlCol="0" anchor="ctr"/>
-          <a:lstStyle/>
-          <a:p>
-            <a:pPr algn="ctr"/>
-          </a:p>
-        </p:txBody>
-      </p:sp>
-      <p:sp>
-        <p:nvSpPr>
-          <p:cNvPr id="31" name="Rectangle 30"/>
-          <p:cNvSpPr/>
-          <p:nvPr/>
-        </p:nvSpPr>
-        <p:spPr>
-          <a:xfrm>
-            <a:off x="2457450" y="3143250"/>
-            <a:ext cx="857250" cy="114300"/>
-          </a:xfrm>
-          <a:prstGeom prst="rect">
-            <a:avLst/>
-          </a:prstGeom>
-          <a:solidFill>
-            <a:srgbClr val="78A9D8"/>
-          </a:solidFill>
-          <a:ln>
-            <a:noFill/>
-          </a:ln>
-          <a:effectLst/>
-        </p:spPr>
-        <p:style>
-          <a:lnRef idx="1">
-            <a:schemeClr val="accent1"/>
-          </a:lnRef>
-          <a:fillRef idx="3">
-            <a:schemeClr val="accent1"/>
-          </a:fillRef>
-          <a:effectRef idx="2">
-            <a:schemeClr val="accent1"/>
-          </a:effectRef>
-          <a:fontRef idx="minor">
-            <a:schemeClr val="lt1"/>
-          </a:fontRef>
-        </p:style>
-        <p:txBody>
-          <a:bodyPr rtlCol="0" anchor="ctr"/>
-          <a:lstStyle/>
-          <a:p>
-            <a:pPr algn="ctr"/>
-          </a:p>
-        </p:txBody>
-      </p:sp>
-      <p:sp>
-        <p:nvSpPr>
-          <p:cNvPr id="32" name="TextBox 31"/>
-          <p:cNvSpPr txBox="1"/>
-          <p:nvPr/>
-        </p:nvSpPr>
-        <p:spPr>
-          <a:xfrm>
-            <a:off x="4248150" y="3124200"/>
-            <a:ext cx="419100" cy="152400"/>
-          </a:xfrm>
-          <a:prstGeom prst="rect">
-            <a:avLst/>
-          </a:prstGeom>
-          <a:noFill/>
-        </p:spPr>
-        <p:txBody>
-          <a:bodyPr wrap="square" anchor="t" lIns="0" rIns="0" tIns="0" bIns="0">
-            <a:spAutoFit/>
-          </a:bodyPr>
-          <a:lstStyle/>
-          <a:p>
-            <a:pPr algn="l">
-              <a:lnSpc>
-                <a:spcPct val="106000"/>
-              </a:lnSpc>
-            </a:pPr>
-            <a:r>
-              <a:rPr sz="1100" b="1">
-                <a:solidFill>
-                  <a:srgbClr val="182238"/>
-                </a:solidFill>
-                <a:latin typeface="Aptos"/>
-              </a:rPr>
-              <a:t>77</a:t>
+              <a:t>49</a:t>
             </a:r>
           </a:p>
         </p:txBody>
@@ -9259,7 +9259,7 @@
                 </a:solidFill>
                 <a:latin typeface="Aptos"/>
               </a:rPr>
-              <a:t>1 técnico</a:t>
+              <a:t>2 técnicos</a:t>
             </a:r>
           </a:p>
         </p:txBody>
@@ -9298,7 +9298,7 @@
                 </a:solidFill>
                 <a:latin typeface="Aptos"/>
               </a:rPr>
-              <a:t>ficou sem nenhuma baixa no período inteiro (01–07/07): Adrian Viana de França (C.32, GA Roberval Silva Rodrigues) — capacidade fora de campo a confirmar com RH/escala, mesmo padrão do Ceará, mas em escala muito menor (1 caso, não 7).</a:t>
+              <a:t>ficaram sem nenhuma baixa no período inteiro (01–09/07): Israel Costa da Silva (C.32, GA Naan Carlos Cabral Oliveira) e Luis Henrique Mendes Costa (C.32, GA Francisco Sales Furtado Jr.) — capacidade fora de campo a confirmar com RH/escala, mesmo padrão do Ceará, mas em escala muito menor (2 casos, não 7).</a:t>
             </a:r>
           </a:p>
         </p:txBody>
@@ -9427,7 +9427,7 @@
                           </a:solidFill>
                           <a:latin typeface="Aptos"/>
                         </a:rPr>
-                        <a:t>1 técnico sem baixa no período</a:t>
+                        <a:t>2 técnicos sem baixa no período</a:t>
                       </a:r>
                     </a:p>
                     <a:p>
@@ -9443,7 +9443,7 @@
                           </a:solidFill>
                           <a:latin typeface="Aptos"/>
                         </a:rPr>
-                        <a:t>Adrian Viana de França (C.32)</a:t>
+                        <a:t>Israel Costa da Silva e Luis Henrique Mendes Costa (C.32)</a:t>
                       </a:r>
                     </a:p>
                   </a:txBody>
@@ -9470,7 +9470,7 @@
                           </a:solidFill>
                           <a:latin typeface="Aptos"/>
                         </a:rPr>
-                        <a:t>Nenhuma OS concluída entre 01 e 07/07. Não é baixa produtividade: é capacidade fora de campo.</a:t>
+                        <a:t>Nenhuma OS concluída entre 01 e 09/07. Não é baixa produtividade: é capacidade fora de campo.</a:t>
                       </a:r>
                     </a:p>
                   </a:txBody>
@@ -9542,7 +9542,7 @@
                           </a:solidFill>
                           <a:latin typeface="Aptos"/>
                         </a:rPr>
-                        <a:t>David Wesllem de Sousa Baldez e Natan Padilha Pinheiro (gap 15); Antonio Pedro de Oliveira (13); Alex Henrique Carvalho Duarte e Andre Santos Pereira (12); Felipe Sousa Quirino e Flavio Antonio Estevam Arouche (11); Emanuel Bezerra Lima (10) — todos C.32</a:t>
+                        <a:t>Andre Santos Pereira e Natan Padilha Pinheiro (gap 19); David Wesllem de Sousa Baldez (17); Marcio Andre Cutrim Costa e Lucas dos Santos Cutrim (14); Antonio Pedro de Oliveira, Gabriel Leite Barbosa e Felipe Sousa Quirino (13) — todos C.32</a:t>
                       </a:r>
                     </a:p>
                   </a:txBody>
@@ -9569,7 +9569,7 @@
                           </a:solidFill>
                           <a:latin typeface="Aptos"/>
                         </a:rPr>
-                        <a:t>Concentram boa parte do gap do Maranhão; todos com poucos dias trabalhados no período (4 a 5 de 7).</a:t>
+                        <a:t>Concentram boa parte do gap do Maranhão; a maioria com poucos dias trabalhados no período (4 a 7 de 9).</a:t>
                       </a:r>
                     </a:p>
                   </a:txBody>
@@ -9641,7 +9641,7 @@
                           </a:solidFill>
                           <a:latin typeface="Aptos"/>
                         </a:rPr>
-                        <a:t>Emisson Barbosa Paiva (5,6) e Lucas Sousa Silva (5,4) — C.32; Werbert Pereira dos Santos (5,6), Claudiomir de Sousa (5,25) e Rafael Costa Lima (5,0) — C.31</a:t>
+                        <a:t>Emisson Barbosa Paiva (5,86) e Lucas Sousa Silva (5,29) — C.32; Werbert Pereira dos Santos (5,57), Claudiomir de Sousa (5,50) e Rafael Costa Lima (5,43) — C.31</a:t>
                       </a:r>
                     </a:p>
                   </a:txBody>
@@ -9832,7 +9832,7 @@
                 </a:solidFill>
                 <a:latin typeface="Aptos"/>
               </a:rPr>
-              <a:t>1</a:t>
+              <a:t>2</a:t>
             </a:r>
           </a:p>
         </p:txBody>
@@ -10164,7 +10164,7 @@
                 </a:solidFill>
                 <a:latin typeface="Aptos"/>
               </a:rPr>
-              <a:t>32</a:t>
+              <a:t>38</a:t>
             </a:r>
           </a:p>
         </p:txBody>
@@ -10330,7 +10330,7 @@
                 </a:solidFill>
                 <a:latin typeface="Aptos"/>
               </a:rPr>
-              <a:t>32</a:t>
+              <a:t>41</a:t>
             </a:r>
           </a:p>
         </p:txBody>
@@ -10496,7 +10496,7 @@
                 </a:solidFill>
                 <a:latin typeface="Aptos"/>
               </a:rPr>
-              <a:t>54</a:t>
+              <a:t>47</a:t>
             </a:r>
           </a:p>
         </p:txBody>
@@ -11088,7 +11088,7 @@
                           </a:solidFill>
                           <a:latin typeface="Aptos"/>
                         </a:rPr>
-                        <a:t>Maranhão abaixo em Prazo e Produção</a:t>
+                        <a:t>Maranhão volta a cumprir o Prazo 24h, mas Produção e Agenda seguem abaixo</a:t>
                       </a:r>
                     </a:p>
                     <a:p>
@@ -11104,7 +11104,7 @@
                           </a:solidFill>
                           <a:latin typeface="Aptos"/>
                         </a:rPr>
-                        <a:t>Prazo 24h 77,6% · Produção 82,1% do esperado, em 06/07</a:t>
+                        <a:t>Prazo 24h 89,4% (meta 85%) · Produção 88,4% do esperado · Cumprimento de Agenda 72,3%, em 08/07</a:t>
                       </a:r>
                     </a:p>
                   </a:txBody>
@@ -11131,7 +11131,7 @@
                           </a:solidFill>
                           <a:latin typeface="Aptos"/>
                         </a:rPr>
-                        <a:t>O gap de produção está concentrado em poucas áreas de gestão e técnicos específicos, detalhados na página anterior.</a:t>
+                        <a:t>O gap de produção segue concentrado em poucas áreas de gestão e técnicos específicos, detalhados na página anterior; a queda de Cumprimento de Agenda é mais recente e ainda em apuração.</a:t>
                       </a:r>
                     </a:p>
                   </a:txBody>
@@ -11158,7 +11158,7 @@
                           </a:solidFill>
                           <a:latin typeface="Aptos"/>
                         </a:rPr>
-                        <a:t>Controle diário de Prazo e Presença nas áreas críticas, com lista nominal e providência no mesmo dia.</a:t>
+                        <a:t>Controle diário de Produção e Agenda nas áreas críticas, sustentando o ganho de Prazo 24h, com lista nominal e providência no mesmo dia.</a:t>
                       </a:r>
                     </a:p>
                   </a:txBody>
@@ -11185,7 +11185,7 @@
                           </a:solidFill>
                           <a:latin typeface="Aptos"/>
                         </a:rPr>
-                        <a:t>08/07</a:t>
+                        <a:t>10/07</a:t>
                       </a:r>
                     </a:p>
                     <a:p>
@@ -11201,7 +11201,7 @@
                           </a:solidFill>
                           <a:latin typeface="Aptos"/>
                         </a:rPr>
-                        <a:t>1ª revisão 15/07</a:t>
+                        <a:t>1ª revisão 17/07</a:t>
                       </a:r>
                     </a:p>
                   </a:txBody>
@@ -11255,7 +11255,7 @@
                           </a:solidFill>
                           <a:latin typeface="Aptos"/>
                         </a:rPr>
-                        <a:t>A iniciar</a:t>
+                        <a:t>Em andamento</a:t>
                       </a:r>
                     </a:p>
                   </a:txBody>
@@ -11284,7 +11284,7 @@
                           </a:solidFill>
                           <a:latin typeface="Aptos"/>
                         </a:rPr>
-                        <a:t>364 OS de gap estimado em 7 dias</a:t>
+                        <a:t>419 OS de gap estimado em 9 dias</a:t>
                       </a:r>
                     </a:p>
                     <a:p>
@@ -11327,7 +11327,7 @@
                           </a:solidFill>
                           <a:latin typeface="Aptos"/>
                         </a:rPr>
-                        <a:t>1 técnico sem nenhuma baixa no período; 8 com maior desvio individual, a maioria com só 4–5 dos 7 dias trabalhados.</a:t>
+                        <a:t>2 técnicos sem nenhuma baixa no período; 8 com maior desvio individual, a maioria com 4 a 7 dos 9 dias trabalhados.</a:t>
                       </a:r>
                     </a:p>
                   </a:txBody>
@@ -11354,7 +11354,7 @@
                           </a:solidFill>
                           <a:latin typeface="Aptos"/>
                         </a:rPr>
-                        <a:t>Confirmar com RH a situação do técnico parado; plano individual para os 8 críticos; ajuste de carga e rota para os demais.</a:t>
+                        <a:t>Confirmar com RH a situação dos 2 técnicos parados; plano individual para os 8 críticos; ajuste de carga e rota para os demais.</a:t>
                       </a:r>
                     </a:p>
                   </a:txBody>
@@ -11381,7 +11381,7 @@
                           </a:solidFill>
                           <a:latin typeface="Aptos"/>
                         </a:rPr>
-                        <a:t>08/07</a:t>
+                        <a:t>10/07</a:t>
                       </a:r>
                     </a:p>
                     <a:p>
@@ -11397,7 +11397,7 @@
                           </a:solidFill>
                           <a:latin typeface="Aptos"/>
                         </a:rPr>
-                        <a:t>planos até 10/07</a:t>
+                        <a:t>planos até 12/07</a:t>
                       </a:r>
                     </a:p>
                   </a:txBody>
@@ -11480,7 +11480,7 @@
                           </a:solidFill>
                           <a:latin typeface="Aptos"/>
                         </a:rPr>
-                        <a:t>189 visitas improdutivas no período</a:t>
+                        <a:t>273 visitas improdutivas no período</a:t>
                       </a:r>
                     </a:p>
                     <a:p>
@@ -11496,7 +11496,7 @@
                           </a:solidFill>
                           <a:latin typeface="Aptos"/>
                         </a:rPr>
-                        <a:t>125 com motivo registrado</a:t>
+                        <a:t>174 com motivo registrado</a:t>
                       </a:r>
                     </a:p>
                   </a:txBody>
@@ -11523,7 +11523,7 @@
                           </a:solidFill>
                           <a:latin typeface="Aptos"/>
                         </a:rPr>
-                        <a:t>Abertura indevida (30) e Falha massiva (26) lideram os motivos registrados — 74% das classificadas nascem antes do despacho.</a:t>
+                        <a:t>Abertura indevida (39) e Falha massiva (37) lideram os motivos registrados — 74% das classificadas nascem antes do despacho.</a:t>
                       </a:r>
                     </a:p>
                   </a:txBody>
@@ -11577,7 +11577,7 @@
                           </a:solidFill>
                           <a:latin typeface="Aptos"/>
                         </a:rPr>
-                        <a:t>08/07</a:t>
+                        <a:t>10/07</a:t>
                       </a:r>
                     </a:p>
                     <a:p>
@@ -11593,7 +11593,7 @@
                           </a:solidFill>
                           <a:latin typeface="Aptos"/>
                         </a:rPr>
-                        <a:t>travas até 10/07</a:t>
+                        <a:t>travas até 12/07</a:t>
                       </a:r>
                     </a:p>
                   </a:txBody>
@@ -11676,7 +11676,7 @@
                           </a:solidFill>
                           <a:latin typeface="Aptos"/>
                         </a:rPr>
-                        <a:t>Queda de 30% na Produção 11 OK (S27→S28)</a:t>
+                        <a:t>Recuperação parcial da Produção 11 OK (S27→S28)</a:t>
                       </a:r>
                     </a:p>
                     <a:p>
@@ -11692,7 +11692,7 @@
                           </a:solidFill>
                           <a:latin typeface="Aptos"/>
                         </a:rPr>
-                        <a:t>3,25 → 2,27 OS/dia</a:t>
+                        <a:t>3,25 → 3,02 OS/dia (-7,1%)</a:t>
                       </a:r>
                     </a:p>
                   </a:txBody>
@@ -11719,7 +11719,7 @@
                           </a:solidFill>
                           <a:latin typeface="Aptos"/>
                         </a:rPr>
-                        <a:t>Concentrada no Maranhão, mesma regional que já está abaixo da meta de Prazo e Produção no fechamento diário.</a:t>
+                        <a:t>Concentrada no Maranhão, mesma regional que segue abaixo da meta de Produção e de Cumprimento de Agenda no fechamento diário.</a:t>
                       </a:r>
                     </a:p>
                   </a:txBody>
@@ -11746,7 +11746,7 @@
                           </a:solidFill>
                           <a:latin typeface="Aptos"/>
                         </a:rPr>
-                        <a:t>Acompanhar o fechamento da S28 frente à S27, priorizando as GAs com maior gap identificado (Naan Carlos Cabral Oliveira, Roberval Silva Rodrigues, Francisco Sales Furtado Jr.).</a:t>
+                        <a:t>Acompanhar o fechamento da S28 frente à S27, priorizando as GAs com maior gap identificado (Naan Carlos Cabral Oliveira, Leonardo Cardoso Silva, Francisco Sales Furtado Jr.).</a:t>
                       </a:r>
                     </a:p>
                   </a:txBody>
@@ -12019,7 +12019,7 @@
                 </a:solidFill>
                 <a:latin typeface="Aptos"/>
               </a:rPr>
-              <a:t>Confirmar responsáveis e prazos   ·   Ratificar 85% como meta do Prazo 24h para a regional   ·   Priorizar a GA de Naan Carlos Cabral Oliveira na recuperação</a:t>
+              <a:t>Confirmar responsáveis e prazos   ·   Ratificar 85% como meta do Prazo 24h e do Cumprimento de Agenda para a regional   ·   Priorizar a GA de Naan Carlos Cabral Oliveira na recuperação</a:t>
             </a:r>
           </a:p>
         </p:txBody>

</xml_diff>

<commit_message>
Padroniza tabela do painel MA/PI com coluna Presenca (como no Ceara)
Troca "Baixando servico" por "Presenca" (meta minima 95%) e remove
"Cumprimento de Agenda" da tabela de status, alinhando com o layout
do painel do Ceara. Adiciona modificador .cols-4 no CSS compartilhado,
escopado para nao afetar as tabelas de 5 colunas do Ceara/Nordeste.

Co-Authored-By: Claude Sonnet 5 <noreply@anthropic.com>
</commit_message>
<xml_diff>
--- a/outputs/3ps/3Ps_MaranhaoPiaui_Executivo.pptx
+++ b/outputs/3ps/3Ps_MaranhaoPiaui_Executivo.pptx
@@ -3521,7 +3521,7 @@
                           </a:solidFill>
                           <a:latin typeface="Aptos"/>
                         </a:rPr>
-                        <a:t>Baixando serviço</a:t>
+                        <a:t>Presença</a:t>
                       </a:r>
                     </a:p>
                     <a:p>
@@ -3537,7 +3537,7 @@
                           </a:solidFill>
                           <a:latin typeface="Aptos"/>
                         </a:rPr>
-                        <a:t>vs. folha meta, 08/07</a:t>
+                        <a:t>meta mínima 95%</a:t>
                       </a:r>
                     </a:p>
                   </a:txBody>
@@ -3695,7 +3695,7 @@
                           </a:solidFill>
                           <a:latin typeface="Aptos"/>
                         </a:rPr>
-                        <a:t>78,9%</a:t>
+                        <a:t>114,3%</a:t>
                       </a:r>
                     </a:p>
                     <a:p>
@@ -3711,7 +3711,7 @@
                           </a:solidFill>
                           <a:latin typeface="Aptos"/>
                         </a:rPr>
-                        <a:t>15 de 19 da folha meta</a:t>
+                        <a:t>19,3 p.p. acima da meta</a:t>
                       </a:r>
                     </a:p>
                   </a:txBody>
@@ -3865,11 +3865,11 @@
                       <a:r>
                         <a:rPr sz="1600" b="1">
                           <a:solidFill>
-                            <a:srgbClr val="9A6200"/>
+                            <a:srgbClr val="13853A"/>
                           </a:solidFill>
                           <a:latin typeface="Aptos"/>
                         </a:rPr>
-                        <a:t>78,2%</a:t>
+                        <a:t>100,0%</a:t>
                       </a:r>
                     </a:p>
                     <a:p>
@@ -3885,7 +3885,7 @@
                           </a:solidFill>
                           <a:latin typeface="Aptos"/>
                         </a:rPr>
-                        <a:t>43 de 55 da folha meta</a:t>
+                        <a:t>5,0 p.p. acima da meta</a:t>
                       </a:r>
                     </a:p>
                   </a:txBody>
@@ -4020,7 +4020,7 @@
                 </a:solidFill>
                 <a:latin typeface="Aptos"/>
               </a:rPr>
-              <a:t>Como ler: Baixando Serviço mede quantos técnicos da folha meta estão de fato executando ordens no dia. A regional R7.2 fechou 08/07 com Prazo 24h em 90,3% (acima da meta) e Cumprimento de Agenda em 75,0% — abaixo da meta de 85%, puxado pelo Maranhão.</a:t>
+              <a:t>Como ler: Presença mede o quadro efetivamente disponível para operar frente à necessidade mínima do dia. A regional R7.2 fechou 08/07 com Prazo 24h em 90,3% (acima da meta) e Cumprimento de Agenda em 75,0% — abaixo da meta de 85%, puxado pelo Maranhão.</a:t>
             </a:r>
           </a:p>
         </p:txBody>

</xml_diff>

<commit_message>
Exclui tecnico em ferias da base do painel MA/PI
Luis Henrique Mendes Costa estava de ferias o periodo inteiro
(01-09/07, confirmado via periodo_ferias no Analitico Acompanhamento
Tecnicos) e nao deveria contar como "sem baixa" nem no quadro
elegivel. Remove ele de todas as bases (69 -> 68 tecnicos) e recalcula
quartis, tenure mix e o headline de Q1/NP.

Tambem identificados 4 tecnicos com ferias parciais que zeravam uma
das duas semanas por licenca, nao por improdutividade (Helton Rafael
Reis de Sousa - S27, Felix Machado Oliveira, Carlos Henrique Freitas
Gomes e Antonio Ferreira de Carvalho Cunha - S28); a semana de ferias
de cada um foi excluida do calculo de quartil (NP so deve refletir
quem estava disponivel e nao produziu). Gap por cluster/GA e o
ranking dos 8 maiores desvios nao mudam, pois ja eram calculados a
partir do volume real trabalhado.

Co-Authored-By: Claude Sonnet 5 <noreply@anthropic.com>
</commit_message>
<xml_diff>
--- a/outputs/3ps/3Ps_MaranhaoPiaui_Executivo.pptx
+++ b/outputs/3ps/3Ps_MaranhaoPiaui_Executivo.pptx
@@ -4231,7 +4231,7 @@
                 </a:solidFill>
                 <a:latin typeface="Aptos"/>
               </a:rPr>
-              <a:t>20 de 69</a:t>
+              <a:t>18 de 68</a:t>
             </a:r>
           </a:p>
         </p:txBody>
@@ -4949,7 +4949,7 @@
                 </a:solidFill>
                 <a:latin typeface="Aptos"/>
               </a:rPr>
-              <a:t>69 técnicos elegíveis</a:t>
+              <a:t>68 técnicos elegíveis</a:t>
             </a:r>
           </a:p>
         </p:txBody>
@@ -5027,7 +5027,7 @@
                 </a:solidFill>
                 <a:latin typeface="Aptos"/>
               </a:rPr>
-              <a:t>Quartil de produtividade (11 OK), média das semanas S27 e S28. Quadro concentrado em &gt;90 dias de casa: 16 de 18 no Piauí, 47 de 51 no Maranhão.</a:t>
+              <a:t>Quartil de produtividade (11 OK), média das semanas S27 e S28. Quadro concentrado em &gt;90 dias de casa: 16 de 18 no Piauí, 46 de 50 no Maranhão.</a:t>
             </a:r>
           </a:p>
         </p:txBody>
@@ -5041,7 +5041,7 @@
         <p:spPr>
           <a:xfrm>
             <a:off x="742950" y="2114550"/>
-            <a:ext cx="1838382" cy="190500"/>
+            <a:ext cx="1919249" cy="190500"/>
           </a:xfrm>
           <a:prstGeom prst="rect">
             <a:avLst/>
@@ -5084,8 +5084,8 @@
         </p:nvSpPr>
         <p:spPr>
           <a:xfrm>
-            <a:off x="2581332" y="2114550"/>
-            <a:ext cx="1601171" cy="190500"/>
+            <a:off x="2662199" y="2114550"/>
+            <a:ext cx="1676647" cy="190500"/>
           </a:xfrm>
           <a:prstGeom prst="rect">
             <a:avLst/>
@@ -5128,8 +5128,8 @@
         </p:nvSpPr>
         <p:spPr>
           <a:xfrm>
-            <a:off x="4182503" y="2114550"/>
-            <a:ext cx="1482566" cy="190500"/>
+            <a:off x="4338847" y="2114550"/>
+            <a:ext cx="1552651" cy="190500"/>
           </a:xfrm>
           <a:prstGeom prst="rect">
             <a:avLst/>
@@ -5172,8 +5172,8 @@
         </p:nvSpPr>
         <p:spPr>
           <a:xfrm>
-            <a:off x="5665069" y="2114550"/>
-            <a:ext cx="469030" cy="190500"/>
+            <a:off x="5891498" y="2114550"/>
+            <a:ext cx="242601" cy="190500"/>
           </a:xfrm>
           <a:prstGeom prst="rect">
             <a:avLst/>
@@ -5286,7 +5286,7 @@
                 </a:solidFill>
                 <a:latin typeface="Aptos"/>
               </a:rPr>
-              <a:t>34,1%</a:t>
+              <a:t>35,6%</a:t>
             </a:r>
           </a:p>
           <a:p>
@@ -5388,7 +5388,7 @@
                 </a:solidFill>
                 <a:latin typeface="Aptos"/>
               </a:rPr>
-              <a:t>29,7%</a:t>
+              <a:t>31,1%</a:t>
             </a:r>
           </a:p>
           <a:p>
@@ -5490,7 +5490,7 @@
                 </a:solidFill>
                 <a:latin typeface="Aptos"/>
               </a:rPr>
-              <a:t>27,5%</a:t>
+              <a:t>28,8%</a:t>
             </a:r>
           </a:p>
           <a:p>
@@ -5592,7 +5592,7 @@
                 </a:solidFill>
                 <a:latin typeface="Aptos"/>
               </a:rPr>
-              <a:t>8,7%</a:t>
+              <a:t>4,5%</a:t>
             </a:r>
           </a:p>
           <a:p>
@@ -6226,7 +6226,7 @@
                 </a:solidFill>
                 <a:latin typeface="Aptos"/>
               </a:rPr>
-              <a:t>2 técnicos (Israel Costa da Silva e Luis Henrique Mendes Costa, C.32) ficaram sem nenhuma baixa no período inteiro — confirmar com RH/escala.</a:t>
+              <a:t>1 técnico (Israel Costa da Silva, C.32) ficou sem nenhuma baixa no período inteiro — confirmar com RH/escala.</a:t>
             </a:r>
           </a:p>
         </p:txBody>
@@ -8059,7 +8059,7 @@
                 </a:solidFill>
                 <a:latin typeface="Aptos"/>
               </a:rPr>
-              <a:t>Fonte: Analítico Nominal por técnico, 01 a 09/07/2026 · 69 técnicos elegíveis · gap estimado, dias trabalhados inferidos</a:t>
+              <a:t>Fonte: Analítico Nominal por técnico, 01 a 09/07/2026 · 68 técnicos elegíveis · gap estimado, dias trabalhados inferidos</a:t>
             </a:r>
           </a:p>
         </p:txBody>
@@ -9259,7 +9259,7 @@
                 </a:solidFill>
                 <a:latin typeface="Aptos"/>
               </a:rPr>
-              <a:t>2 técnicos</a:t>
+              <a:t>1 técnico</a:t>
             </a:r>
           </a:p>
         </p:txBody>
@@ -9298,7 +9298,7 @@
                 </a:solidFill>
                 <a:latin typeface="Aptos"/>
               </a:rPr>
-              <a:t>ficaram sem nenhuma baixa no período inteiro (01–09/07): Israel Costa da Silva (C.32, GA Naan Carlos Cabral Oliveira) e Luis Henrique Mendes Costa (C.32, GA Francisco Sales Furtado Jr.) — capacidade fora de campo a confirmar com RH/escala, mesmo padrão do Ceará, mas em escala muito menor (2 casos, não 7).</a:t>
+              <a:t>ficou sem nenhuma baixa no período inteiro (01–09/07): Israel Costa da Silva (C.32, GA Naan Carlos Cabral Oliveira) — capacidade fora de campo a confirmar com RH/escala, mesmo padrão do Ceará, mas em escala muito menor (1 caso, não 7).</a:t>
             </a:r>
           </a:p>
         </p:txBody>
@@ -9427,7 +9427,7 @@
                           </a:solidFill>
                           <a:latin typeface="Aptos"/>
                         </a:rPr>
-                        <a:t>2 técnicos sem baixa no período</a:t>
+                        <a:t>1 técnico sem baixa no período</a:t>
                       </a:r>
                     </a:p>
                     <a:p>
@@ -9443,7 +9443,7 @@
                           </a:solidFill>
                           <a:latin typeface="Aptos"/>
                         </a:rPr>
-                        <a:t>Israel Costa da Silva e Luis Henrique Mendes Costa (C.32)</a:t>
+                        <a:t>Israel Costa da Silva (C.32)</a:t>
                       </a:r>
                     </a:p>
                   </a:txBody>
@@ -9832,7 +9832,7 @@
                 </a:solidFill>
                 <a:latin typeface="Aptos"/>
               </a:rPr>
-              <a:t>2</a:t>
+              <a:t>1</a:t>
             </a:r>
           </a:p>
         </p:txBody>
@@ -11327,7 +11327,7 @@
                           </a:solidFill>
                           <a:latin typeface="Aptos"/>
                         </a:rPr>
-                        <a:t>2 técnicos sem nenhuma baixa no período; 8 com maior desvio individual, a maioria com 4 a 7 dos 9 dias trabalhados.</a:t>
+                        <a:t>1 técnico sem nenhuma baixa no período; 8 com maior desvio individual, a maioria com 4 a 7 dos 9 dias trabalhados.</a:t>
                       </a:r>
                     </a:p>
                   </a:txBody>
@@ -11354,7 +11354,7 @@
                           </a:solidFill>
                           <a:latin typeface="Aptos"/>
                         </a:rPr>
-                        <a:t>Confirmar com RH a situação dos 2 técnicos parados; plano individual para os 8 críticos; ajuste de carga e rota para os demais.</a:t>
+                        <a:t>Confirmar com RH a situação do técnico parado; plano individual para os 8 críticos; ajuste de carga e rota para os demais.</a:t>
                       </a:r>
                     </a:p>
                   </a:txBody>

</xml_diff>

<commit_message>
Adiciona coluna Fila acumulada ao painel MA/PI
A base de backlog (aba "hist Backlog" da planilha nacional de
tecnicos sem producao) tem historico diario de fila por cluster,
inclusive C.31 e C.32 -- ao contrario do que a analise anterior
supunha. Em 08/07: Piaui 0,79 dia e Maranhao 0,68 dia, ambos dentro
do limite de 1 dia. Volta a tabela de 5 colunas (igual ao Ceara) e
remove o modificador .cols-4, que nao e mais necessario.

Co-Authored-By: Claude Sonnet 5 <noreply@anthropic.com>
</commit_message>
<xml_diff>
--- a/outputs/3ps/3Ps_MaranhaoPiaui_Executivo.pptx
+++ b/outputs/3ps/3Ps_MaranhaoPiaui_Executivo.pptx
@@ -3447,7 +3447,7 @@
                 </a:solidFill>
                 <a:latin typeface="Aptos"/>
               </a:rPr>
-              <a:t>No fechamento de 08/07, o Maranhão (C.32) passou a cumprir a meta de Prazo 24h, mas segue abaixo do esperado em Produção; o Piauí (C.31) está com folga confortável em Produção e Prazo. O Cumprimento de Agenda caiu nos dois clusters e é hoje o principal ponto de atenção. Na visão semanal, a Produção 11 OK da regional caiu de 3,25 para 3,02 OS/dia (-7,1%) entre a semana fechada (S27) e a semana em curso (S28).</a:t>
+              <a:t>No fechamento de 08/07, o Maranhão (C.32) passou a cumprir a meta de Prazo 24h, mas segue abaixo do esperado em Produção; o Piauí (C.31) está com folga confortável em Produção e Prazo. O Cumprimento de Agenda caiu nos dois clusters e é hoje o principal ponto de atenção — a fila de ordens, porém, está dentro do limite de 1 dia nos dois clusters. Na visão semanal, a Produção 11 OK da regional caiu de 3,25 para 3,02 OS/dia (-7,1%) entre a semana fechada (S27) e a semana em curso (S28).</a:t>
             </a:r>
           </a:p>
         </p:txBody>
@@ -3471,10 +3471,11 @@
                 <a:tableStyleId>{5C22544A-7EE6-4342-B048-85BDC9FD1C3A}</a:tableStyleId>
               </a:tblPr>
               <a:tblGrid>
-                <a:gridCol w="2190750"/>
-                <a:gridCol w="2914650"/>
-                <a:gridCol w="2914650"/>
-                <a:gridCol w="3105150"/>
+                <a:gridCol w="1905000"/>
+                <a:gridCol w="2247900"/>
+                <a:gridCol w="2381250"/>
+                <a:gridCol w="2247900"/>
+                <a:gridCol w="2343150"/>
               </a:tblGrid>
               <a:tr h="647700">
                 <a:tc>
@@ -3624,6 +3625,49 @@
                           <a:latin typeface="Aptos"/>
                         </a:rPr>
                         <a:t>meta 85% das ordens</a:t>
+                      </a:r>
+                    </a:p>
+                  </a:txBody>
+                  <a:tcPr anchor="ctr" marL="95250" marR="76200" marT="57150" marB="57150">
+                    <a:solidFill>
+                      <a:srgbClr val="081551"/>
+                    </a:solidFill>
+                  </a:tcPr>
+                </a:tc>
+                <a:tc>
+                  <a:txBody>
+                    <a:bodyPr wrap="square"/>
+                    <a:lstStyle/>
+                    <a:p>
+                      <a:pPr algn="l">
+                        <a:lnSpc>
+                          <a:spcPct val="105000"/>
+                        </a:lnSpc>
+                      </a:pPr>
+                      <a:r>
+                        <a:rPr sz="1300" b="1">
+                          <a:solidFill>
+                            <a:srgbClr val="FFFFFF"/>
+                          </a:solidFill>
+                          <a:latin typeface="Aptos"/>
+                        </a:rPr>
+                        <a:t>Fila acumulada</a:t>
+                      </a:r>
+                    </a:p>
+                    <a:p>
+                      <a:pPr algn="l">
+                        <a:lnSpc>
+                          <a:spcPct val="105000"/>
+                        </a:lnSpc>
+                      </a:pPr>
+                      <a:r>
+                        <a:rPr sz="950" b="0">
+                          <a:solidFill>
+                            <a:srgbClr val="BFC9E3"/>
+                          </a:solidFill>
+                          <a:latin typeface="Aptos"/>
+                        </a:rPr>
+                        <a:t>em dias de trabalho, 08/07</a:t>
                       </a:r>
                     </a:p>
                   </a:txBody>
@@ -3807,6 +3851,49 @@
                     </a:solidFill>
                   </a:tcPr>
                 </a:tc>
+                <a:tc>
+                  <a:txBody>
+                    <a:bodyPr wrap="square"/>
+                    <a:lstStyle/>
+                    <a:p>
+                      <a:pPr algn="l">
+                        <a:lnSpc>
+                          <a:spcPct val="105000"/>
+                        </a:lnSpc>
+                      </a:pPr>
+                      <a:r>
+                        <a:rPr sz="1600" b="1">
+                          <a:solidFill>
+                            <a:srgbClr val="13853A"/>
+                          </a:solidFill>
+                          <a:latin typeface="Aptos"/>
+                        </a:rPr>
+                        <a:t>0,79 dia</a:t>
+                      </a:r>
+                    </a:p>
+                    <a:p>
+                      <a:pPr algn="l">
+                        <a:lnSpc>
+                          <a:spcPct val="105000"/>
+                        </a:lnSpc>
+                      </a:pPr>
+                      <a:r>
+                        <a:rPr sz="1000" b="0">
+                          <a:solidFill>
+                            <a:srgbClr val="667085"/>
+                          </a:solidFill>
+                          <a:latin typeface="Aptos"/>
+                        </a:rPr>
+                        <a:t>dentro do limite</a:t>
+                      </a:r>
+                    </a:p>
+                  </a:txBody>
+                  <a:tcPr anchor="ctr" marL="95250" marR="76200" marT="57150" marB="57150">
+                    <a:solidFill>
+                      <a:srgbClr val="FFFFFF"/>
+                    </a:solidFill>
+                  </a:tcPr>
+                </a:tc>
               </a:tr>
               <a:tr h="647700">
                 <a:tc>
@@ -3981,6 +4068,49 @@
                     </a:solidFill>
                   </a:tcPr>
                 </a:tc>
+                <a:tc>
+                  <a:txBody>
+                    <a:bodyPr wrap="square"/>
+                    <a:lstStyle/>
+                    <a:p>
+                      <a:pPr algn="l">
+                        <a:lnSpc>
+                          <a:spcPct val="105000"/>
+                        </a:lnSpc>
+                      </a:pPr>
+                      <a:r>
+                        <a:rPr sz="1600" b="1">
+                          <a:solidFill>
+                            <a:srgbClr val="13853A"/>
+                          </a:solidFill>
+                          <a:latin typeface="Aptos"/>
+                        </a:rPr>
+                        <a:t>0,68 dia</a:t>
+                      </a:r>
+                    </a:p>
+                    <a:p>
+                      <a:pPr algn="l">
+                        <a:lnSpc>
+                          <a:spcPct val="105000"/>
+                        </a:lnSpc>
+                      </a:pPr>
+                      <a:r>
+                        <a:rPr sz="1000" b="0">
+                          <a:solidFill>
+                            <a:srgbClr val="667085"/>
+                          </a:solidFill>
+                          <a:latin typeface="Aptos"/>
+                        </a:rPr>
+                        <a:t>dentro do limite</a:t>
+                      </a:r>
+                    </a:p>
+                  </a:txBody>
+                  <a:tcPr anchor="ctr" marL="95250" marR="76200" marT="57150" marB="57150">
+                    <a:solidFill>
+                      <a:srgbClr val="EAF2FB"/>
+                    </a:solidFill>
+                  </a:tcPr>
+                </a:tc>
               </a:tr>
             </a:tbl>
           </a:graphicData>
@@ -4020,7 +4150,7 @@
                 </a:solidFill>
                 <a:latin typeface="Aptos"/>
               </a:rPr>
-              <a:t>Como ler: Presença mede o quadro efetivamente disponível para operar frente à necessidade mínima do dia. A regional R7.2 fechou 08/07 com Prazo 24h em 90,3% (acima da meta) e Cumprimento de Agenda em 75,0% — abaixo da meta de 85%, puxado pelo Maranhão.</a:t>
+              <a:t>Como ler: Presença mede o quadro efetivamente disponível para operar frente à necessidade mínima do dia; Fila indica quantos dias de trabalho seriam necessários para zerar as ordens em aberto, sem entrada de novas OS. A regional R7.2 fechou 08/07 com Prazo 24h em 90,3% (acima da meta) e Cumprimento de Agenda em 75,0% — abaixo da meta de 85%, puxado pelo Maranhão.</a:t>
             </a:r>
           </a:p>
         </p:txBody>

</xml_diff>

<commit_message>
Corrige faixas de gap do slide 3 do PPT MA/PI (somavam mais que o headcount)
As 5 caixas misturavam tecnicos distintos (sem baixa, maiores desvios)
com registros-semana do quartil (Q1/Q2/Q3, que contam cada tecnico ate
2x, em S27 e S28) -- por isso a soma dava 135 em vez de bater com os
68 elegiveis. Troca as 3 ultimas caixas por faixas de gap severity
(desvio medio, quase na meta, na meta), replicando a logica do painel
do Ceara, onde as 5 faixas somam exatamente o headcount.

Co-Authored-By: Claude Sonnet 5 <noreply@anthropic.com>
</commit_message>
<xml_diff>
--- a/outputs/3ps/3Ps_MaranhaoPiaui_Executivo.pptx
+++ b/outputs/3ps/3Ps_MaranhaoPiaui_Executivo.pptx
@@ -10167,7 +10167,7 @@
                 </a:solidFill>
                 <a:latin typeface="Aptos"/>
               </a:rPr>
-              <a:t>maior desvio individual — plano já</a:t>
+              <a:t>desvio crítico, 29% da perda — plano individual já</a:t>
             </a:r>
           </a:p>
         </p:txBody>
@@ -10294,7 +10294,7 @@
                 </a:solidFill>
                 <a:latin typeface="Aptos"/>
               </a:rPr>
-              <a:t>38</a:t>
+              <a:t>30</a:t>
             </a:r>
           </a:p>
         </p:txBody>
@@ -10333,7 +10333,7 @@
                 </a:solidFill>
                 <a:latin typeface="Aptos"/>
               </a:rPr>
-              <a:t>Q1 — abaixo da mediana</a:t>
+              <a:t>desvio médio (5 a 13 OS) — conversa até 12/07</a:t>
             </a:r>
           </a:p>
         </p:txBody>
@@ -10460,7 +10460,7 @@
                 </a:solidFill>
                 <a:latin typeface="Aptos"/>
               </a:rPr>
-              <a:t>41</a:t>
+              <a:t>15</a:t>
             </a:r>
           </a:p>
         </p:txBody>
@@ -10499,7 +10499,7 @@
                 </a:solidFill>
                 <a:latin typeface="Aptos"/>
               </a:rPr>
-              <a:t>Q2 — na mediana</a:t>
+              <a:t>quase na meta (1 a 4 OS) — ajuste de carga e rota</a:t>
             </a:r>
           </a:p>
         </p:txBody>
@@ -10626,7 +10626,7 @@
                 </a:solidFill>
                 <a:latin typeface="Aptos"/>
               </a:rPr>
-              <a:t>47</a:t>
+              <a:t>14</a:t>
             </a:r>
           </a:p>
         </p:txBody>
@@ -10665,7 +10665,7 @@
                 </a:solidFill>
                 <a:latin typeface="Aptos"/>
               </a:rPr>
-              <a:t>Q3 — acima da mediana, usar de referência</a:t>
+              <a:t>na meta — reconhecer e usar de referência</a:t>
             </a:r>
           </a:p>
         </p:txBody>

</xml_diff>

<commit_message>
Troca faixas de gap por produtividade relativa a meta no slide 3
As 3 caixas de severidade agora usam % da meta atingida (Prod. OK /
meta por tempo de casa) em vez de OS de desvio: <70% (22 tecnicos),
70-100% (23) e >=100% (14, mesma contagem de "na meta" de antes, ja
que produtividade >=100% da meta equivale a gap zero). Soma continua
batendo com os 68 elegiveis.

Co-Authored-By: Claude Sonnet 5 <noreply@anthropic.com>
</commit_message>
<xml_diff>
--- a/outputs/3ps/3Ps_MaranhaoPiaui_Executivo.pptx
+++ b/outputs/3ps/3Ps_MaranhaoPiaui_Executivo.pptx
@@ -9581,7 +9581,7 @@
                 </a:solidFill>
                 <a:latin typeface="Aptos"/>
               </a:rPr>
-              <a:t>30</a:t>
+              <a:t>22</a:t>
             </a:r>
           </a:p>
         </p:txBody>
@@ -9620,7 +9620,7 @@
                 </a:solidFill>
                 <a:latin typeface="Aptos"/>
               </a:rPr>
-              <a:t>desvio médio (5 a 13 OS) — conversa até 12/07</a:t>
+              <a:t>produtividade baixa (&lt; 70% da meta) — conversa até 12/07</a:t>
             </a:r>
           </a:p>
         </p:txBody>
@@ -9747,7 +9747,7 @@
                 </a:solidFill>
                 <a:latin typeface="Aptos"/>
               </a:rPr>
-              <a:t>15</a:t>
+              <a:t>23</a:t>
             </a:r>
           </a:p>
         </p:txBody>
@@ -9786,7 +9786,7 @@
                 </a:solidFill>
                 <a:latin typeface="Aptos"/>
               </a:rPr>
-              <a:t>quase na meta (1 a 4 OS) — ajuste de carga e rota</a:t>
+              <a:t>produtividade média (70 a 100% da meta) — ajuste de carga e rota</a:t>
             </a:r>
           </a:p>
         </p:txBody>
@@ -9952,7 +9952,7 @@
                 </a:solidFill>
                 <a:latin typeface="Aptos"/>
               </a:rPr>
-              <a:t>na meta — reconhecer e usar de referência</a:t>
+              <a:t>na meta (100% ou mais) — reconhecer e usar de referência</a:t>
             </a:r>
           </a:p>
         </p:txBody>

</xml_diff>